<commit_message>
cup50: all three VLMs on all 50 clips; fused final verdict 35/15 (30% failure), 27/50 unanimous
PaliGemma re-run with the direct 'is the cup resting on the saucer?'
question: its late p(done) range went from 0.28-0.65 (hedging) to
0.07-0.97. Report, README, slide numbers refreshed.

Co-Authored-By: Claude Opus 5 (1M context) <noreply@anthropic.com>
</commit_message>
<xml_diff>
--- a/SLIDE.pptx
+++ b/SLIDE.pptx
@@ -3362,7 +3362,7 @@
                             <a:srgbClr val="111111"/>
                           </a:solidFill>
                         </a:rPr>
-                        <a:t>SAM 3 cup-in-saucer test on 50 human clips → 28% failure</a:t>
+                        <a:t>SAM 3 + 3 VLMs fused on 50 human clips → 30% failure</a:t>
                       </a:r>
                     </a:p>
                   </a:txBody>
@@ -3949,7 +3949,7 @@
                             <a:srgbClr val="111111"/>
                           </a:solidFill>
                         </a:rPr>
-                        <a:t>cup50 short clips (n=8, end of clip)</a:t>
+                        <a:t>cup50 clips (n=50, end of clip)</a:t>
                       </a:r>
                     </a:p>
                   </a:txBody>
@@ -3970,7 +3970,7 @@
                             <a:srgbClr val="111111"/>
                           </a:solidFill>
                         </a:rPr>
-                        <a:t>8/9 ✅</a:t>
+                        <a:t>39/50 ✅</a:t>
                       </a:r>
                     </a:p>
                   </a:txBody>
@@ -3991,7 +3991,7 @@
                             <a:srgbClr val="111111"/>
                           </a:solidFill>
                         </a:rPr>
-                        <a:t>3/8</a:t>
+                        <a:t>42/50</a:t>
                       </a:r>
                     </a:p>
                   </a:txBody>
@@ -4012,7 +4012,7 @@
                             <a:srgbClr val="111111"/>
                           </a:solidFill>
                         </a:rPr>
-                        <a:t>7/8</a:t>
+                        <a:t>34/50</a:t>
                       </a:r>
                     </a:p>
                   </a:txBody>
@@ -4033,7 +4033,7 @@
                             <a:srgbClr val="111111"/>
                           </a:solidFill>
                         </a:rPr>
-                        <a:t>36/50 → 28% fail</a:t>
+                        <a:t>fused 35/50 → 30% fail</a:t>
                       </a:r>
                     </a:p>
                   </a:txBody>

</xml_diff>

<commit_message>
Slide + README rewritten for the full 50-clip, three-VLM results
Co-Authored-By: Claude Opus 5 (1M context) <noreply@anthropic.com>
</commit_message>
<xml_diff>
--- a/SLIDE.pptx
+++ b/SLIDE.pptx
@@ -3112,7 +3112,7 @@
           <a:p>
             <a:pPr>
               <a:lnSpc>
-                <a:spcPct val="115000"/>
+                <a:spcPct val="112000"/>
               </a:lnSpc>
             </a:pPr>
             <a:r>
@@ -3144,8 +3144,8 @@
         </p:nvSpPr>
         <p:spPr>
           <a:xfrm>
-            <a:off x="457200" y="1051560"/>
-            <a:ext cx="6949440" cy="320040"/>
+            <a:off x="457200" y="1005840"/>
+            <a:ext cx="6949440" cy="292608"/>
           </a:xfrm>
           <a:prstGeom prst="rect">
             <a:avLst/>
@@ -3160,11 +3160,11 @@
           <a:p>
             <a:pPr>
               <a:lnSpc>
-                <a:spcPct val="115000"/>
+                <a:spcPct val="112000"/>
               </a:lnSpc>
             </a:pPr>
             <a:r>
-              <a:rPr sz="1300" b="1" i="0">
+              <a:rPr sz="1250" b="1" i="0">
                 <a:solidFill>
                   <a:srgbClr val="1982C4"/>
                 </a:solidFill>
@@ -3184,8 +3184,8 @@
           <p:nvPr/>
         </p:nvGraphicFramePr>
         <p:xfrm>
-          <a:off x="457200" y="1371600"/>
-          <a:ext cx="6949440" cy="1097280"/>
+          <a:off x="457200" y="1298448"/>
+          <a:ext cx="6949440" cy="1024128"/>
         </p:xfrm>
         <a:graphic>
           <a:graphicData uri="http://schemas.openxmlformats.org/drawingml/2006/table">
@@ -3194,17 +3194,17 @@
                 <a:tableStyleId>{5C22544A-7EE6-4342-B048-85BDC9FD1C3A}</a:tableStyleId>
               </a:tblPr>
               <a:tblGrid>
-                <a:gridCol w="1554480"/>
-                <a:gridCol w="5394960"/>
+                <a:gridCol w="1463040"/>
+                <a:gridCol w="5486400"/>
               </a:tblGrid>
-              <a:tr h="274320">
+              <a:tr h="256032">
                 <a:tc>
                   <a:txBody>
-                    <a:bodyPr wrap="square"/>
+                    <a:bodyPr/>
                     <a:lstStyle/>
                     <a:p>
                       <a:r>
-                        <a:rPr sz="1000" b="1">
+                        <a:rPr b="1" sz="950">
                           <a:solidFill>
                             <a:srgbClr val="555555"/>
                           </a:solidFill>
@@ -3213,7 +3213,7 @@
                       </a:r>
                     </a:p>
                   </a:txBody>
-                  <a:tcPr marL="54864" marR="54864" marT="27432" marB="27432">
+                  <a:tcPr marL="45720" marR="45720" marT="18288" marB="18288">
                     <a:solidFill>
                       <a:srgbClr val="F7F9FC"/>
                     </a:solidFill>
@@ -3221,11 +3221,11 @@
                 </a:tc>
                 <a:tc>
                   <a:txBody>
-                    <a:bodyPr wrap="square"/>
+                    <a:bodyPr/>
                     <a:lstStyle/>
                     <a:p>
                       <a:r>
-                        <a:rPr sz="1000" b="1">
+                        <a:rPr b="1" sz="950">
                           <a:solidFill>
                             <a:srgbClr val="555555"/>
                           </a:solidFill>
@@ -3234,21 +3234,21 @@
                       </a:r>
                     </a:p>
                   </a:txBody>
-                  <a:tcPr marL="54864" marR="54864" marT="27432" marB="27432">
+                  <a:tcPr marL="45720" marR="45720" marT="18288" marB="18288">
                     <a:solidFill>
                       <a:srgbClr val="F7F9FC"/>
                     </a:solidFill>
                   </a:tcPr>
                 </a:tc>
               </a:tr>
-              <a:tr h="274320">
+              <a:tr h="256032">
                 <a:tc>
                   <a:txBody>
-                    <a:bodyPr wrap="square"/>
+                    <a:bodyPr/>
                     <a:lstStyle/>
                     <a:p>
                       <a:r>
-                        <a:rPr sz="1100" b="0">
+                        <a:rPr b="0" sz="1050">
                           <a:solidFill>
                             <a:srgbClr val="111111"/>
                           </a:solidFill>
@@ -3257,7 +3257,7 @@
                       </a:r>
                     </a:p>
                   </a:txBody>
-                  <a:tcPr marL="54864" marR="54864" marT="27432" marB="27432">
+                  <a:tcPr marL="45720" marR="45720" marT="18288" marB="18288">
                     <a:solidFill>
                       <a:srgbClr val="FFFFFF"/>
                     </a:solidFill>
@@ -3265,34 +3265,34 @@
                 </a:tc>
                 <a:tc>
                   <a:txBody>
-                    <a:bodyPr wrap="square"/>
+                    <a:bodyPr/>
                     <a:lstStyle/>
                     <a:p>
                       <a:r>
-                        <a:rPr sz="1100" b="0">
+                        <a:rPr b="0" sz="1050">
                           <a:solidFill>
                             <a:srgbClr val="111111"/>
                           </a:solidFill>
                         </a:rPr>
-                        <a:t>success/failure per episode from per-frame p(goal state) read from Qwen3-VL / Cosmos-Reason2 / PaliGemma logits</a:t>
+                        <a:t>success/failure per episode from per-frame p(cup on saucer) read from Qwen3-VL / Cosmos-Reason2 / PaliGemma logits</a:t>
                       </a:r>
                     </a:p>
                   </a:txBody>
-                  <a:tcPr marL="54864" marR="54864" marT="27432" marB="27432">
+                  <a:tcPr marL="45720" marR="45720" marT="18288" marB="18288">
                     <a:solidFill>
                       <a:srgbClr val="FFFFFF"/>
                     </a:solidFill>
                   </a:tcPr>
                 </a:tc>
               </a:tr>
-              <a:tr h="274320">
+              <a:tr h="256032">
                 <a:tc>
                   <a:txBody>
-                    <a:bodyPr wrap="square"/>
+                    <a:bodyPr/>
                     <a:lstStyle/>
                     <a:p>
                       <a:r>
-                        <a:rPr sz="1100" b="0">
+                        <a:rPr b="0" sz="1050">
                           <a:solidFill>
                             <a:srgbClr val="111111"/>
                           </a:solidFill>
@@ -3301,7 +3301,7 @@
                       </a:r>
                     </a:p>
                   </a:txBody>
-                  <a:tcPr marL="54864" marR="54864" marT="27432" marB="27432">
+                  <a:tcPr marL="45720" marR="45720" marT="18288" marB="18288">
                     <a:solidFill>
                       <a:srgbClr val="FFFFFF"/>
                     </a:solidFill>
@@ -3309,11 +3309,11 @@
                 </a:tc>
                 <a:tc>
                   <a:txBody>
-                    <a:bodyPr wrap="square"/>
+                    <a:bodyPr/>
                     <a:lstStyle/>
                     <a:p>
                       <a:r>
-                        <a:rPr sz="1100" b="0">
+                        <a:rPr b="0" sz="1050">
                           <a:solidFill>
                             <a:srgbClr val="111111"/>
                           </a:solidFill>
@@ -3322,21 +3322,21 @@
                       </a:r>
                     </a:p>
                   </a:txBody>
-                  <a:tcPr marL="54864" marR="54864" marT="27432" marB="27432">
+                  <a:tcPr marL="45720" marR="45720" marT="18288" marB="18288">
                     <a:solidFill>
                       <a:srgbClr val="FFFFFF"/>
                     </a:solidFill>
                   </a:tcPr>
                 </a:tc>
               </a:tr>
-              <a:tr h="274320">
+              <a:tr h="256032">
                 <a:tc>
                   <a:txBody>
-                    <a:bodyPr wrap="square"/>
+                    <a:bodyPr/>
                     <a:lstStyle/>
                     <a:p>
                       <a:r>
-                        <a:rPr sz="1100" b="0">
+                        <a:rPr b="0" sz="1050">
                           <a:solidFill>
                             <a:srgbClr val="111111"/>
                           </a:solidFill>
@@ -3345,7 +3345,7 @@
                       </a:r>
                     </a:p>
                   </a:txBody>
-                  <a:tcPr marL="54864" marR="54864" marT="27432" marB="27432">
+                  <a:tcPr marL="45720" marR="45720" marT="18288" marB="18288">
                     <a:solidFill>
                       <a:srgbClr val="FFFFFF"/>
                     </a:solidFill>
@@ -3353,20 +3353,20 @@
                 </a:tc>
                 <a:tc>
                   <a:txBody>
-                    <a:bodyPr wrap="square"/>
+                    <a:bodyPr/>
                     <a:lstStyle/>
                     <a:p>
                       <a:r>
-                        <a:rPr sz="1100" b="0">
+                        <a:rPr b="0" sz="1050">
                           <a:solidFill>
                             <a:srgbClr val="111111"/>
                           </a:solidFill>
                         </a:rPr>
-                        <a:t>SAM 3 + 3 VLMs fused on 50 human clips → 30% failure</a:t>
+                        <a:t>SAM 3 + 3 VLMs on all 50 human clips → 30% failure (27/50 unanimous)</a:t>
                       </a:r>
                     </a:p>
                   </a:txBody>
-                  <a:tcPr marL="54864" marR="54864" marT="27432" marB="27432">
+                  <a:tcPr marL="45720" marR="45720" marT="18288" marB="18288">
                     <a:solidFill>
                       <a:srgbClr val="FFFFFF"/>
                     </a:solidFill>
@@ -3385,8 +3385,8 @@
         </p:nvSpPr>
         <p:spPr>
           <a:xfrm>
-            <a:off x="457200" y="3063240"/>
-            <a:ext cx="6949440" cy="320040"/>
+            <a:off x="457200" y="2788920"/>
+            <a:ext cx="6949440" cy="292608"/>
           </a:xfrm>
           <a:prstGeom prst="rect">
             <a:avLst/>
@@ -3401,11 +3401,11 @@
           <a:p>
             <a:pPr>
               <a:lnSpc>
-                <a:spcPct val="115000"/>
+                <a:spcPct val="112000"/>
               </a:lnSpc>
             </a:pPr>
             <a:r>
-              <a:rPr sz="1300" b="1" i="0">
+              <a:rPr sz="1250" b="1" i="0">
                 <a:solidFill>
                   <a:srgbClr val="1982C4"/>
                 </a:solidFill>
@@ -3432,8 +3432,8 @@
         </p:blipFill>
         <p:spPr>
           <a:xfrm>
-            <a:off x="457200" y="3383280"/>
-            <a:ext cx="2331720" cy="2331720"/>
+            <a:off x="457200" y="3108960"/>
+            <a:ext cx="2011680" cy="2011680"/>
           </a:xfrm>
           <a:prstGeom prst="rect">
             <a:avLst/>
@@ -3449,8 +3449,8 @@
           <p:nvPr/>
         </p:nvGraphicFramePr>
         <p:xfrm>
-          <a:off x="2971800" y="3429000"/>
-          <a:ext cx="4434840" cy="1097280"/>
+          <a:off x="2651760" y="3154680"/>
+          <a:ext cx="4754880" cy="1024128"/>
         </p:xfrm>
         <a:graphic>
           <a:graphicData uri="http://schemas.openxmlformats.org/drawingml/2006/table">
@@ -3459,18 +3459,18 @@
                 <a:tableStyleId>{5C22544A-7EE6-4342-B048-85BDC9FD1C3A}</a:tableStyleId>
               </a:tblPr>
               <a:tblGrid>
-                <a:gridCol w="2788920"/>
+                <a:gridCol w="3108960"/>
                 <a:gridCol w="731520"/>
                 <a:gridCol w="914400"/>
               </a:tblGrid>
-              <a:tr h="274320">
+              <a:tr h="256032">
                 <a:tc>
                   <a:txBody>
-                    <a:bodyPr wrap="square"/>
+                    <a:bodyPr/>
                     <a:lstStyle/>
                     <a:p>
                       <a:r>
-                        <a:rPr sz="1000" b="1">
+                        <a:rPr b="1" sz="950">
                           <a:solidFill>
                             <a:srgbClr val="555555"/>
                           </a:solidFill>
@@ -3479,7 +3479,7 @@
                       </a:r>
                     </a:p>
                   </a:txBody>
-                  <a:tcPr marL="54864" marR="54864" marT="27432" marB="27432">
+                  <a:tcPr marL="45720" marR="45720" marT="18288" marB="18288">
                     <a:solidFill>
                       <a:srgbClr val="F7F9FC"/>
                     </a:solidFill>
@@ -3487,11 +3487,11 @@
                 </a:tc>
                 <a:tc>
                   <a:txBody>
-                    <a:bodyPr wrap="square"/>
+                    <a:bodyPr/>
                     <a:lstStyle/>
                     <a:p>
                       <a:r>
-                        <a:rPr sz="1000" b="1">
+                        <a:rPr b="1" sz="950">
                           <a:solidFill>
                             <a:srgbClr val="555555"/>
                           </a:solidFill>
@@ -3500,7 +3500,7 @@
                       </a:r>
                     </a:p>
                   </a:txBody>
-                  <a:tcPr marL="54864" marR="54864" marT="27432" marB="27432">
+                  <a:tcPr marL="45720" marR="45720" marT="18288" marB="18288">
                     <a:solidFill>
                       <a:srgbClr val="F7F9FC"/>
                     </a:solidFill>
@@ -3508,11 +3508,11 @@
                 </a:tc>
                 <a:tc>
                   <a:txBody>
-                    <a:bodyPr wrap="square"/>
+                    <a:bodyPr/>
                     <a:lstStyle/>
                     <a:p>
                       <a:r>
-                        <a:rPr sz="1000" b="1">
+                        <a:rPr b="1" sz="950">
                           <a:solidFill>
                             <a:srgbClr val="555555"/>
                           </a:solidFill>
@@ -3521,21 +3521,21 @@
                       </a:r>
                     </a:p>
                   </a:txBody>
-                  <a:tcPr marL="54864" marR="54864" marT="27432" marB="27432">
+                  <a:tcPr marL="45720" marR="45720" marT="18288" marB="18288">
                     <a:solidFill>
                       <a:srgbClr val="F7F9FC"/>
                     </a:solidFill>
                   </a:tcPr>
                 </a:tc>
               </a:tr>
-              <a:tr h="274320">
+              <a:tr h="256032">
                 <a:tc>
                   <a:txBody>
-                    <a:bodyPr wrap="square"/>
+                    <a:bodyPr/>
                     <a:lstStyle/>
                     <a:p>
                       <a:r>
-                        <a:rPr sz="1100" b="0">
+                        <a:rPr b="0" sz="1050">
                           <a:solidFill>
                             <a:srgbClr val="111111"/>
                           </a:solidFill>
@@ -3544,7 +3544,7 @@
                       </a:r>
                     </a:p>
                   </a:txBody>
-                  <a:tcPr marL="54864" marR="54864" marT="27432" marB="27432">
+                  <a:tcPr marL="45720" marR="45720" marT="18288" marB="18288">
                     <a:solidFill>
                       <a:srgbClr val="FFFFFF"/>
                     </a:solidFill>
@@ -3552,11 +3552,11 @@
                 </a:tc>
                 <a:tc>
                   <a:txBody>
-                    <a:bodyPr wrap="square"/>
+                    <a:bodyPr/>
                     <a:lstStyle/>
                     <a:p>
                       <a:r>
-                        <a:rPr sz="1100" b="0">
+                        <a:rPr b="0" sz="1050">
                           <a:solidFill>
                             <a:srgbClr val="111111"/>
                           </a:solidFill>
@@ -3565,7 +3565,7 @@
                       </a:r>
                     </a:p>
                   </a:txBody>
-                  <a:tcPr marL="54864" marR="54864" marT="27432" marB="27432">
+                  <a:tcPr marL="45720" marR="45720" marT="18288" marB="18288">
                     <a:solidFill>
                       <a:srgbClr val="FFFFFF"/>
                     </a:solidFill>
@@ -3573,11 +3573,11 @@
                 </a:tc>
                 <a:tc>
                   <a:txBody>
-                    <a:bodyPr wrap="square"/>
+                    <a:bodyPr/>
                     <a:lstStyle/>
                     <a:p>
                       <a:r>
-                        <a:rPr sz="1100" b="1">
+                        <a:rPr b="1" sz="1050">
                           <a:solidFill>
                             <a:srgbClr val="111111"/>
                           </a:solidFill>
@@ -3586,21 +3586,21 @@
                       </a:r>
                     </a:p>
                   </a:txBody>
-                  <a:tcPr marL="54864" marR="54864" marT="27432" marB="27432">
+                  <a:tcPr marL="45720" marR="45720" marT="18288" marB="18288">
                     <a:solidFill>
                       <a:srgbClr val="FFFFFF"/>
                     </a:solidFill>
                   </a:tcPr>
                 </a:tc>
               </a:tr>
-              <a:tr h="274320">
+              <a:tr h="256032">
                 <a:tc>
                   <a:txBody>
-                    <a:bodyPr wrap="square"/>
+                    <a:bodyPr/>
                     <a:lstStyle/>
                     <a:p>
                       <a:r>
-                        <a:rPr sz="1100" b="0">
+                        <a:rPr b="0" sz="1050">
                           <a:solidFill>
                             <a:srgbClr val="111111"/>
                           </a:solidFill>
@@ -3609,7 +3609,7 @@
                       </a:r>
                     </a:p>
                   </a:txBody>
-                  <a:tcPr marL="54864" marR="54864" marT="27432" marB="27432">
+                  <a:tcPr marL="45720" marR="45720" marT="18288" marB="18288">
                     <a:solidFill>
                       <a:srgbClr val="FFFFFF"/>
                     </a:solidFill>
@@ -3617,11 +3617,11 @@
                 </a:tc>
                 <a:tc>
                   <a:txBody>
-                    <a:bodyPr wrap="square"/>
+                    <a:bodyPr/>
                     <a:lstStyle/>
                     <a:p>
                       <a:r>
-                        <a:rPr sz="1100" b="0">
+                        <a:rPr b="0" sz="1050">
                           <a:solidFill>
                             <a:srgbClr val="111111"/>
                           </a:solidFill>
@@ -3630,7 +3630,7 @@
                       </a:r>
                     </a:p>
                   </a:txBody>
-                  <a:tcPr marL="54864" marR="54864" marT="27432" marB="27432">
+                  <a:tcPr marL="45720" marR="45720" marT="18288" marB="18288">
                     <a:solidFill>
                       <a:srgbClr val="FFFFFF"/>
                     </a:solidFill>
@@ -3638,11 +3638,11 @@
                 </a:tc>
                 <a:tc>
                   <a:txBody>
-                    <a:bodyPr wrap="square"/>
+                    <a:bodyPr/>
                     <a:lstStyle/>
                     <a:p>
                       <a:r>
-                        <a:rPr sz="1100" b="0">
+                        <a:rPr b="0" sz="1050">
                           <a:solidFill>
                             <a:srgbClr val="111111"/>
                           </a:solidFill>
@@ -3651,21 +3651,21 @@
                       </a:r>
                     </a:p>
                   </a:txBody>
-                  <a:tcPr marL="54864" marR="54864" marT="27432" marB="27432">
+                  <a:tcPr marL="45720" marR="45720" marT="18288" marB="18288">
                     <a:solidFill>
                       <a:srgbClr val="FFFFFF"/>
                     </a:solidFill>
                   </a:tcPr>
                 </a:tc>
               </a:tr>
-              <a:tr h="274320">
+              <a:tr h="256032">
                 <a:tc>
                   <a:txBody>
-                    <a:bodyPr wrap="square"/>
+                    <a:bodyPr/>
                     <a:lstStyle/>
                     <a:p>
                       <a:r>
-                        <a:rPr sz="1100" b="0">
+                        <a:rPr b="0" sz="1050">
                           <a:solidFill>
                             <a:srgbClr val="111111"/>
                           </a:solidFill>
@@ -3674,7 +3674,7 @@
                       </a:r>
                     </a:p>
                   </a:txBody>
-                  <a:tcPr marL="54864" marR="54864" marT="27432" marB="27432">
+                  <a:tcPr marL="45720" marR="45720" marT="18288" marB="18288">
                     <a:solidFill>
                       <a:srgbClr val="FFFFFF"/>
                     </a:solidFill>
@@ -3682,11 +3682,11 @@
                 </a:tc>
                 <a:tc>
                   <a:txBody>
-                    <a:bodyPr wrap="square"/>
+                    <a:bodyPr/>
                     <a:lstStyle/>
                     <a:p>
                       <a:r>
-                        <a:rPr sz="1100" b="0">
+                        <a:rPr b="0" sz="1050">
                           <a:solidFill>
                             <a:srgbClr val="111111"/>
                           </a:solidFill>
@@ -3695,7 +3695,7 @@
                       </a:r>
                     </a:p>
                   </a:txBody>
-                  <a:tcPr marL="54864" marR="54864" marT="27432" marB="27432">
+                  <a:tcPr marL="45720" marR="45720" marT="18288" marB="18288">
                     <a:solidFill>
                       <a:srgbClr val="FFFFFF"/>
                     </a:solidFill>
@@ -3703,11 +3703,11 @@
                 </a:tc>
                 <a:tc>
                   <a:txBody>
-                    <a:bodyPr wrap="square"/>
+                    <a:bodyPr/>
                     <a:lstStyle/>
                     <a:p>
                       <a:r>
-                        <a:rPr sz="1100" b="0">
+                        <a:rPr b="0" sz="1050">
                           <a:solidFill>
                             <a:srgbClr val="111111"/>
                           </a:solidFill>
@@ -3716,7 +3716,7 @@
                       </a:r>
                     </a:p>
                   </a:txBody>
-                  <a:tcPr marL="54864" marR="54864" marT="27432" marB="27432">
+                  <a:tcPr marL="45720" marR="45720" marT="18288" marB="18288">
                     <a:solidFill>
                       <a:srgbClr val="FFFFFF"/>
                     </a:solidFill>
@@ -3735,8 +3735,8 @@
         </p:nvSpPr>
         <p:spPr>
           <a:xfrm>
-            <a:off x="2971800" y="4709160"/>
-            <a:ext cx="4434840" cy="822960"/>
+            <a:off x="2651760" y="4297680"/>
+            <a:ext cx="4754880" cy="548640"/>
           </a:xfrm>
           <a:prstGeom prst="rect">
             <a:avLst/>
@@ -3751,17 +3751,17 @@
           <a:p>
             <a:pPr>
               <a:lnSpc>
-                <a:spcPct val="115000"/>
+                <a:spcPct val="112000"/>
               </a:lnSpc>
             </a:pPr>
             <a:r>
-              <a:rPr sz="1100" b="0" i="0">
+              <a:rPr sz="1050" b="0" i="0">
                 <a:solidFill>
                   <a:srgbClr val="555555"/>
                 </a:solidFill>
                 <a:latin typeface="Calibri"/>
               </a:rPr>
-              <a:t>No training. No new labels. Same critic then run on human egocentric video with only the prompts changed.</a:t>
+              <a:t>No training, no new labels. Same critic on human egocentric video with only the prompts changed.</a:t>
             </a:r>
           </a:p>
         </p:txBody>
@@ -3774,8 +3774,8 @@
         </p:nvSpPr>
         <p:spPr>
           <a:xfrm>
-            <a:off x="457200" y="5852160"/>
-            <a:ext cx="6949440" cy="320040"/>
+            <a:off x="457200" y="5257800"/>
+            <a:ext cx="6949440" cy="292608"/>
           </a:xfrm>
           <a:prstGeom prst="rect">
             <a:avLst/>
@@ -3790,17 +3790,17 @@
           <a:p>
             <a:pPr>
               <a:lnSpc>
-                <a:spcPct val="115000"/>
+                <a:spcPct val="112000"/>
               </a:lnSpc>
             </a:pPr>
             <a:r>
-              <a:rPr sz="1300" b="1" i="0">
+              <a:rPr sz="1250" b="1" i="0">
                 <a:solidFill>
                   <a:srgbClr val="1982C4"/>
                 </a:solidFill>
                 <a:latin typeface="Calibri"/>
               </a:rPr>
-              <a:t>UNLABELLED HUMAN VIDEO — THREE VLM LINEAGES, ONE CODE PATH</a:t>
+              <a:t>UNLABELLED HUMAN VIDEO — 50 CLIPS × 4 SIGNALS, ONE CODE PATH</a:t>
             </a:r>
           </a:p>
         </p:txBody>
@@ -3814,8 +3814,8 @@
           <p:nvPr/>
         </p:nvGraphicFramePr>
         <p:xfrm>
-          <a:off x="457200" y="6172200"/>
-          <a:ext cx="6949440" cy="822959"/>
+          <a:off x="457200" y="5559552"/>
+          <a:ext cx="6949440" cy="1024128"/>
         </p:xfrm>
         <a:graphic>
           <a:graphicData uri="http://schemas.openxmlformats.org/drawingml/2006/table">
@@ -3824,29 +3824,27 @@
                 <a:tableStyleId>{5C22544A-7EE6-4342-B048-85BDC9FD1C3A}</a:tableStyleId>
               </a:tblPr>
               <a:tblGrid>
-                <a:gridCol w="2377440"/>
-                <a:gridCol w="1097280"/>
-                <a:gridCol w="1188720"/>
-                <a:gridCol w="1371600"/>
-                <a:gridCol w="914400"/>
+                <a:gridCol w="3474720"/>
+                <a:gridCol w="1737360"/>
+                <a:gridCol w="1737360"/>
               </a:tblGrid>
-              <a:tr h="274319">
+              <a:tr h="256032">
                 <a:tc>
                   <a:txBody>
-                    <a:bodyPr wrap="square"/>
+                    <a:bodyPr/>
                     <a:lstStyle/>
                     <a:p>
                       <a:r>
-                        <a:rPr sz="1000" b="1">
+                        <a:rPr b="1" sz="950">
                           <a:solidFill>
                             <a:srgbClr val="555555"/>
                           </a:solidFill>
                         </a:rPr>
-                        <a:t/>
+                        <a:t>Signal</a:t>
                       </a:r>
                     </a:p>
                   </a:txBody>
-                  <a:tcPr marL="54864" marR="54864" marT="27432" marB="27432">
+                  <a:tcPr marL="45720" marR="45720" marT="18288" marB="18288">
                     <a:solidFill>
                       <a:srgbClr val="F7F9FC"/>
                     </a:solidFill>
@@ -3854,20 +3852,20 @@
                 </a:tc>
                 <a:tc>
                   <a:txBody>
-                    <a:bodyPr wrap="square"/>
+                    <a:bodyPr/>
                     <a:lstStyle/>
                     <a:p>
                       <a:r>
-                        <a:rPr sz="1000" b="1">
+                        <a:rPr b="1" sz="950">
                           <a:solidFill>
                             <a:srgbClr val="555555"/>
                           </a:solidFill>
                         </a:rPr>
-                        <a:t>Qwen3-VL-8B</a:t>
+                        <a:t>Tagged success</a:t>
                       </a:r>
                     </a:p>
                   </a:txBody>
-                  <a:tcPr marL="54864" marR="54864" marT="27432" marB="27432">
+                  <a:tcPr marL="45720" marR="45720" marT="18288" marB="18288">
                     <a:solidFill>
                       <a:srgbClr val="F7F9FC"/>
                     </a:solidFill>
@@ -3875,85 +3873,43 @@
                 </a:tc>
                 <a:tc>
                   <a:txBody>
-                    <a:bodyPr wrap="square"/>
+                    <a:bodyPr/>
                     <a:lstStyle/>
                     <a:p>
                       <a:r>
-                        <a:rPr sz="1000" b="1">
+                        <a:rPr b="1" sz="950">
                           <a:solidFill>
                             <a:srgbClr val="555555"/>
                           </a:solidFill>
                         </a:rPr>
-                        <a:t>PaliGemma2-3B</a:t>
+                        <a:t>Failure prevalence</a:t>
                       </a:r>
                     </a:p>
                   </a:txBody>
-                  <a:tcPr marL="54864" marR="54864" marT="27432" marB="27432">
-                    <a:solidFill>
-                      <a:srgbClr val="F7F9FC"/>
-                    </a:solidFill>
-                  </a:tcPr>
-                </a:tc>
-                <a:tc>
-                  <a:txBody>
-                    <a:bodyPr wrap="square"/>
-                    <a:lstStyle/>
-                    <a:p>
-                      <a:r>
-                        <a:rPr sz="1000" b="1">
-                          <a:solidFill>
-                            <a:srgbClr val="555555"/>
-                          </a:solidFill>
-                        </a:rPr>
-                        <a:t>Cosmos-Reason2-8B</a:t>
-                      </a:r>
-                    </a:p>
-                  </a:txBody>
-                  <a:tcPr marL="54864" marR="54864" marT="27432" marB="27432">
-                    <a:solidFill>
-                      <a:srgbClr val="F7F9FC"/>
-                    </a:solidFill>
-                  </a:tcPr>
-                </a:tc>
-                <a:tc>
-                  <a:txBody>
-                    <a:bodyPr wrap="square"/>
-                    <a:lstStyle/>
-                    <a:p>
-                      <a:r>
-                        <a:rPr sz="1000" b="1">
-                          <a:solidFill>
-                            <a:srgbClr val="555555"/>
-                          </a:solidFill>
-                        </a:rPr>
-                        <a:t>SAM 3</a:t>
-                      </a:r>
-                    </a:p>
-                  </a:txBody>
-                  <a:tcPr marL="54864" marR="54864" marT="27432" marB="27432">
+                  <a:tcPr marL="45720" marR="45720" marT="18288" marB="18288">
                     <a:solidFill>
                       <a:srgbClr val="F7F9FC"/>
                     </a:solidFill>
                   </a:tcPr>
                 </a:tc>
               </a:tr>
-              <a:tr h="274319">
+              <a:tr h="256032">
                 <a:tc>
                   <a:txBody>
-                    <a:bodyPr wrap="square"/>
+                    <a:bodyPr/>
                     <a:lstStyle/>
                     <a:p>
                       <a:r>
-                        <a:rPr sz="1100" b="0">
+                        <a:rPr b="0" sz="1050">
                           <a:solidFill>
                             <a:srgbClr val="111111"/>
                           </a:solidFill>
                         </a:rPr>
-                        <a:t>cup50 clips (n=50, end of clip)</a:t>
+                        <a:t>SAM 3 cup-in-saucer</a:t>
                       </a:r>
                     </a:p>
                   </a:txBody>
-                  <a:tcPr marL="54864" marR="54864" marT="27432" marB="27432">
+                  <a:tcPr marL="45720" marR="45720" marT="18288" marB="18288">
                     <a:solidFill>
                       <a:srgbClr val="FFFFFF"/>
                     </a:solidFill>
@@ -3961,20 +3917,20 @@
                 </a:tc>
                 <a:tc>
                   <a:txBody>
-                    <a:bodyPr wrap="square"/>
+                    <a:bodyPr/>
                     <a:lstStyle/>
                     <a:p>
                       <a:r>
-                        <a:rPr sz="1100" b="0">
+                        <a:rPr b="0" sz="1050">
                           <a:solidFill>
                             <a:srgbClr val="111111"/>
                           </a:solidFill>
                         </a:rPr>
-                        <a:t>39/50 ✅</a:t>
+                        <a:t>36/50</a:t>
                       </a:r>
                     </a:p>
                   </a:txBody>
-                  <a:tcPr marL="54864" marR="54864" marT="27432" marB="27432">
+                  <a:tcPr marL="45720" marR="45720" marT="18288" marB="18288">
                     <a:solidFill>
                       <a:srgbClr val="FFFFFF"/>
                     </a:solidFill>
@@ -3982,20 +3938,43 @@
                 </a:tc>
                 <a:tc>
                   <a:txBody>
-                    <a:bodyPr wrap="square"/>
+                    <a:bodyPr/>
                     <a:lstStyle/>
                     <a:p>
                       <a:r>
-                        <a:rPr sz="1100" b="0">
+                        <a:rPr b="0" sz="1050">
                           <a:solidFill>
                             <a:srgbClr val="111111"/>
                           </a:solidFill>
                         </a:rPr>
-                        <a:t>42/50</a:t>
+                        <a:t>28%</a:t>
                       </a:r>
                     </a:p>
                   </a:txBody>
-                  <a:tcPr marL="54864" marR="54864" marT="27432" marB="27432">
+                  <a:tcPr marL="45720" marR="45720" marT="18288" marB="18288">
+                    <a:solidFill>
+                      <a:srgbClr val="FFFFFF"/>
+                    </a:solidFill>
+                  </a:tcPr>
+                </a:tc>
+              </a:tr>
+              <a:tr h="256032">
+                <a:tc>
+                  <a:txBody>
+                    <a:bodyPr/>
+                    <a:lstStyle/>
+                    <a:p>
+                      <a:r>
+                        <a:rPr b="0" sz="1050">
+                          <a:solidFill>
+                            <a:srgbClr val="111111"/>
+                          </a:solidFill>
+                        </a:rPr>
+                        <a:t>Qwen3-VL-8B · PaliGemma2-3B · Cosmos-Reason2-8B</a:t>
+                      </a:r>
+                    </a:p>
+                  </a:txBody>
+                  <a:tcPr marL="45720" marR="45720" marT="18288" marB="18288">
                     <a:solidFill>
                       <a:srgbClr val="FFFFFF"/>
                     </a:solidFill>
@@ -4003,20 +3982,20 @@
                 </a:tc>
                 <a:tc>
                   <a:txBody>
-                    <a:bodyPr wrap="square"/>
+                    <a:bodyPr/>
                     <a:lstStyle/>
                     <a:p>
                       <a:r>
-                        <a:rPr sz="1100" b="0">
+                        <a:rPr b="0" sz="1050">
                           <a:solidFill>
                             <a:srgbClr val="111111"/>
                           </a:solidFill>
                         </a:rPr>
-                        <a:t>34/50</a:t>
+                        <a:t>39 · 42 · 34 /50</a:t>
                       </a:r>
                     </a:p>
                   </a:txBody>
-                  <a:tcPr marL="54864" marR="54864" marT="27432" marB="27432">
+                  <a:tcPr marL="45720" marR="45720" marT="18288" marB="18288">
                     <a:solidFill>
                       <a:srgbClr val="FFFFFF"/>
                     </a:solidFill>
@@ -4024,43 +4003,43 @@
                 </a:tc>
                 <a:tc>
                   <a:txBody>
-                    <a:bodyPr wrap="square"/>
+                    <a:bodyPr/>
                     <a:lstStyle/>
                     <a:p>
                       <a:r>
-                        <a:rPr sz="1100" b="1">
+                        <a:rPr b="0" sz="1050">
                           <a:solidFill>
                             <a:srgbClr val="111111"/>
                           </a:solidFill>
                         </a:rPr>
-                        <a:t>fused 35/50 → 30% fail</a:t>
+                        <a:t>22 · 16 · 32%</a:t>
                       </a:r>
                     </a:p>
                   </a:txBody>
-                  <a:tcPr marL="54864" marR="54864" marT="27432" marB="27432">
+                  <a:tcPr marL="45720" marR="45720" marT="18288" marB="18288">
                     <a:solidFill>
                       <a:srgbClr val="FFFFFF"/>
                     </a:solidFill>
                   </a:tcPr>
                 </a:tc>
               </a:tr>
-              <a:tr h="274321">
+              <a:tr h="256032">
                 <a:tc>
                   <a:txBody>
-                    <a:bodyPr wrap="square"/>
+                    <a:bodyPr/>
                     <a:lstStyle/>
                     <a:p>
                       <a:r>
-                        <a:rPr sz="1100" b="0">
+                        <a:rPr b="1" sz="1050">
                           <a:solidFill>
                             <a:srgbClr val="111111"/>
                           </a:solidFill>
                         </a:rPr>
-                        <a:t>aria 2-min egocentric (n=8, peak)</a:t>
+                        <a:t>Fused = mean(SEG, mean of VLMs)</a:t>
                       </a:r>
                     </a:p>
                   </a:txBody>
-                  <a:tcPr marL="54864" marR="54864" marT="27432" marB="27432">
+                  <a:tcPr marL="45720" marR="45720" marT="18288" marB="18288">
                     <a:solidFill>
                       <a:srgbClr val="FFFFFF"/>
                     </a:solidFill>
@@ -4068,20 +4047,20 @@
                 </a:tc>
                 <a:tc>
                   <a:txBody>
-                    <a:bodyPr wrap="square"/>
+                    <a:bodyPr/>
                     <a:lstStyle/>
                     <a:p>
                       <a:r>
-                        <a:rPr sz="1100" b="0">
+                        <a:rPr b="1" sz="1050">
                           <a:solidFill>
                             <a:srgbClr val="111111"/>
                           </a:solidFill>
                         </a:rPr>
-                        <a:t>8/8</a:t>
+                        <a:t>35/50</a:t>
                       </a:r>
                     </a:p>
                   </a:txBody>
-                  <a:tcPr marL="54864" marR="54864" marT="27432" marB="27432">
+                  <a:tcPr marL="45720" marR="45720" marT="18288" marB="18288">
                     <a:solidFill>
                       <a:srgbClr val="FFFFFF"/>
                     </a:solidFill>
@@ -4089,62 +4068,20 @@
                 </a:tc>
                 <a:tc>
                   <a:txBody>
-                    <a:bodyPr wrap="square"/>
+                    <a:bodyPr/>
                     <a:lstStyle/>
                     <a:p>
                       <a:r>
-                        <a:rPr sz="1100" b="0">
+                        <a:rPr b="1" sz="1050">
                           <a:solidFill>
                             <a:srgbClr val="111111"/>
                           </a:solidFill>
                         </a:rPr>
-                        <a:t>8/8</a:t>
+                        <a:t>30%</a:t>
                       </a:r>
                     </a:p>
                   </a:txBody>
-                  <a:tcPr marL="54864" marR="54864" marT="27432" marB="27432">
-                    <a:solidFill>
-                      <a:srgbClr val="FFFFFF"/>
-                    </a:solidFill>
-                  </a:tcPr>
-                </a:tc>
-                <a:tc>
-                  <a:txBody>
-                    <a:bodyPr wrap="square"/>
-                    <a:lstStyle/>
-                    <a:p>
-                      <a:r>
-                        <a:rPr sz="1100" b="0">
-                          <a:solidFill>
-                            <a:srgbClr val="111111"/>
-                          </a:solidFill>
-                        </a:rPr>
-                        <a:t>6/8</a:t>
-                      </a:r>
-                    </a:p>
-                  </a:txBody>
-                  <a:tcPr marL="54864" marR="54864" marT="27432" marB="27432">
-                    <a:solidFill>
-                      <a:srgbClr val="FFFFFF"/>
-                    </a:solidFill>
-                  </a:tcPr>
-                </a:tc>
-                <a:tc>
-                  <a:txBody>
-                    <a:bodyPr wrap="square"/>
-                    <a:lstStyle/>
-                    <a:p>
-                      <a:r>
-                        <a:rPr sz="1100" b="0">
-                          <a:solidFill>
-                            <a:srgbClr val="111111"/>
-                          </a:solidFill>
-                        </a:rPr>
-                        <a:t>2/5</a:t>
-                      </a:r>
-                    </a:p>
-                  </a:txBody>
-                  <a:tcPr marL="54864" marR="54864" marT="27432" marB="27432">
+                  <a:tcPr marL="45720" marR="45720" marT="18288" marB="18288">
                     <a:solidFill>
                       <a:srgbClr val="FFFFFF"/>
                     </a:solidFill>
@@ -4163,8 +4100,8 @@
         </p:nvSpPr>
         <p:spPr>
           <a:xfrm>
-            <a:off x="7863840" y="1051560"/>
-            <a:ext cx="6400800" cy="320040"/>
+            <a:off x="457200" y="6629400"/>
+            <a:ext cx="6949440" cy="548640"/>
           </a:xfrm>
           <a:prstGeom prst="rect">
             <a:avLst/>
@@ -4179,11 +4116,50 @@
           <a:p>
             <a:pPr>
               <a:lnSpc>
-                <a:spcPct val="115000"/>
+                <a:spcPct val="112000"/>
               </a:lnSpc>
             </a:pPr>
             <a:r>
-              <a:rPr sz="1300" b="1" i="0">
+              <a:rPr sz="1050" b="0" i="0">
+                <a:solidFill>
+                  <a:srgbClr val="555555"/>
+                </a:solidFill>
+                <a:latin typeface="Calibri"/>
+              </a:rPr>
+              <a:t>27/50 unanimous across all four signals, 37/50 with ≥3 of 4, 6 split 2–2. One 2-min aria video split into 25 attempts → 16 success / 9 failure.</a:t>
+            </a:r>
+          </a:p>
+        </p:txBody>
+      </p:sp>
+      <p:sp>
+        <p:nvSpPr>
+          <p:cNvPr id="12" name="TextBox 11"/>
+          <p:cNvSpPr txBox="1"/>
+          <p:nvPr/>
+        </p:nvSpPr>
+        <p:spPr>
+          <a:xfrm>
+            <a:off x="7863840" y="1005840"/>
+            <a:ext cx="6400800" cy="292608"/>
+          </a:xfrm>
+          <a:prstGeom prst="rect">
+            <a:avLst/>
+          </a:prstGeom>
+          <a:noFill/>
+        </p:spPr>
+        <p:txBody>
+          <a:bodyPr wrap="square" lIns="45720" rIns="45720" tIns="18288" bIns="18288">
+            <a:spAutoFit/>
+          </a:bodyPr>
+          <a:lstStyle/>
+          <a:p>
+            <a:pPr>
+              <a:lnSpc>
+                <a:spcPct val="112000"/>
+              </a:lnSpc>
+            </a:pPr>
+            <a:r>
+              <a:rPr sz="1250" b="1" i="0">
                 <a:solidFill>
                   <a:srgbClr val="1982C4"/>
                 </a:solidFill>
@@ -4196,14 +4172,14 @@
       </p:sp>
       <p:sp>
         <p:nvSpPr>
-          <p:cNvPr id="12" name="Rectangle 11"/>
+          <p:cNvPr id="13" name="Rectangle 12"/>
           <p:cNvSpPr/>
           <p:nvPr/>
         </p:nvSpPr>
         <p:spPr>
           <a:xfrm>
-            <a:off x="7863840" y="1371600"/>
-            <a:ext cx="3017520" cy="1874519"/>
+            <a:off x="7863840" y="1298448"/>
+            <a:ext cx="3017520" cy="1828800"/>
           </a:xfrm>
           <a:prstGeom prst="rect">
             <a:avLst/>
@@ -4241,14 +4217,14 @@
       </p:sp>
       <p:sp>
         <p:nvSpPr>
-          <p:cNvPr id="13" name="TextBox 12"/>
+          <p:cNvPr id="14" name="TextBox 13"/>
           <p:cNvSpPr txBox="1"/>
           <p:nvPr/>
         </p:nvSpPr>
         <p:spPr>
           <a:xfrm>
-            <a:off x="7909560" y="1417320"/>
-            <a:ext cx="2926080" cy="1828800"/>
+            <a:off x="7909560" y="1344168"/>
+            <a:ext cx="2926080" cy="1783080"/>
           </a:xfrm>
           <a:prstGeom prst="rect">
             <a:avLst/>
@@ -4263,7 +4239,7 @@
           <a:p>
             <a:pPr>
               <a:lnSpc>
-                <a:spcPct val="115000"/>
+                <a:spcPct val="112000"/>
               </a:lnSpc>
             </a:pPr>
             <a:r>
@@ -4279,7 +4255,7 @@
           <a:p>
             <a:pPr>
               <a:lnSpc>
-                <a:spcPct val="115000"/>
+                <a:spcPct val="112000"/>
               </a:lnSpc>
             </a:pPr>
             <a:r>
@@ -4289,21 +4265,21 @@
                 </a:solidFill>
                 <a:latin typeface="Calibri"/>
               </a:rPr>
-              <a:t>Every number here came out of a modal run in the repo today: 5 Modal apps, 3 datasets, 3 VLMs, 50 + 20 + 20 episodes. Overlay &amp; meter videos in demo/; graphs, ROC, per-episode verdicts regenerated by one script in results/.</a:t>
-            </a:r>
-          </a:p>
-        </p:txBody>
-      </p:sp>
-      <p:sp>
-        <p:nvSpPr>
-          <p:cNvPr id="14" name="Rectangle 13"/>
+              <a:t>Every number here came out of a modal run in the repo today: 5 Modal apps, 3 datasets, 3 VLMs × all 50 human clips + 20 robot episodes. Overlay &amp; meter videos in demo/; graphs, ROC, per-episode verdicts regenerated by one script in results/.</a:t>
+            </a:r>
+          </a:p>
+        </p:txBody>
+      </p:sp>
+      <p:sp>
+        <p:nvSpPr>
+          <p:cNvPr id="15" name="Rectangle 14"/>
           <p:cNvSpPr/>
           <p:nvPr/>
         </p:nvSpPr>
         <p:spPr>
           <a:xfrm>
-            <a:off x="11018520" y="1371600"/>
-            <a:ext cx="3017520" cy="1874519"/>
+            <a:off x="11018520" y="1298448"/>
+            <a:ext cx="3017520" cy="1828800"/>
           </a:xfrm>
           <a:prstGeom prst="rect">
             <a:avLst/>
@@ -4341,14 +4317,14 @@
       </p:sp>
       <p:sp>
         <p:nvSpPr>
-          <p:cNvPr id="15" name="TextBox 14"/>
+          <p:cNvPr id="16" name="TextBox 15"/>
           <p:cNvSpPr txBox="1"/>
           <p:nvPr/>
         </p:nvSpPr>
         <p:spPr>
           <a:xfrm>
-            <a:off x="11064240" y="1417320"/>
-            <a:ext cx="2926080" cy="1828800"/>
+            <a:off x="11064240" y="1344168"/>
+            <a:ext cx="2926080" cy="1783080"/>
           </a:xfrm>
           <a:prstGeom prst="rect">
             <a:avLst/>
@@ -4363,7 +4339,7 @@
           <a:p>
             <a:pPr>
               <a:lnSpc>
-                <a:spcPct val="115000"/>
+                <a:spcPct val="112000"/>
               </a:lnSpc>
             </a:pPr>
             <a:r>
@@ -4379,7 +4355,7 @@
           <a:p>
             <a:pPr>
               <a:lnSpc>
-                <a:spcPct val="115000"/>
+                <a:spcPct val="112000"/>
               </a:lnSpc>
             </a:pPr>
             <a:r>
@@ -4396,14 +4372,14 @@
       </p:sp>
       <p:sp>
         <p:nvSpPr>
-          <p:cNvPr id="16" name="TextBox 15"/>
+          <p:cNvPr id="17" name="TextBox 16"/>
           <p:cNvSpPr txBox="1"/>
           <p:nvPr/>
         </p:nvSpPr>
         <p:spPr>
           <a:xfrm>
-            <a:off x="7863840" y="3429000"/>
-            <a:ext cx="6400800" cy="320040"/>
+            <a:off x="7863840" y="3291840"/>
+            <a:ext cx="6400800" cy="292608"/>
           </a:xfrm>
           <a:prstGeom prst="rect">
             <a:avLst/>
@@ -4418,11 +4394,11 @@
           <a:p>
             <a:pPr>
               <a:lnSpc>
-                <a:spcPct val="115000"/>
+                <a:spcPct val="112000"/>
               </a:lnSpc>
             </a:pPr>
             <a:r>
-              <a:rPr sz="1300" b="1" i="0">
+              <a:rPr sz="1250" b="1" i="0">
                 <a:solidFill>
                   <a:srgbClr val="1982C4"/>
                 </a:solidFill>
@@ -4435,14 +4411,14 @@
       </p:sp>
       <p:sp>
         <p:nvSpPr>
-          <p:cNvPr id="17" name="TextBox 16"/>
+          <p:cNvPr id="18" name="TextBox 17"/>
           <p:cNvSpPr txBox="1"/>
           <p:nvPr/>
         </p:nvSpPr>
         <p:spPr>
           <a:xfrm>
-            <a:off x="7863840" y="3749039"/>
-            <a:ext cx="6309360" cy="2377440"/>
+            <a:off x="7863840" y="3611880"/>
+            <a:ext cx="6309360" cy="2468880"/>
           </a:xfrm>
           <a:prstGeom prst="rect">
             <a:avLst/>
@@ -4476,7 +4452,7 @@
                 </a:solidFill>
                 <a:latin typeface="Calibri"/>
               </a:rPr>
-              <a:t>The latter is unanswerable from one frame — p(yes) sat at 10⁻⁴ everywhere while the ranking still worked (AUROC 0.73 → 0.83 after the fix). Only visible because we read logits: 0.49 and 0.02 both print "No".</a:t>
+              <a:t>Unanswerable from one frame — p(yes) sat at 10⁻⁴ everywhere while the ranking still worked (AUROC 0.73 → 0.83 after the fix). Smaller model, more literal question: PaliGemma hedged (0.28–0.65) on the generic prompt, decisive (0.07–0.97) on "is the cup resting on the saucer?". Only visible because we read logits.</a:t>
             </a:r>
           </a:p>
           <a:p>
@@ -4517,7 +4493,7 @@
                 </a:solidFill>
                 <a:latin typeface="Calibri"/>
               </a:rPr>
-              <a:t>3. The scoring window must match the video. </a:t>
+              <a:t>3. The unit of evaluation must match the video. </a:t>
             </a:r>
             <a:r>
               <a:rPr sz="1100" b="0" i="0">
@@ -4526,14 +4502,14 @@
                 </a:solidFill>
                 <a:latin typeface="Calibri"/>
               </a:rPr>
-              <a:t>End-of-clip for short demos; peak for long egocentric footage where the person looks away after placing the cup. The same statistic over-calls success on eva (17/20) — so it's a per-dataset choice, stated, both counts shown.</a:t>
-            </a:r>
-          </a:p>
-        </p:txBody>
-      </p:sp>
-      <p:sp>
-        <p:nvSpPr>
-          <p:cNvPr id="18" name="Rectangle 17"/>
+              <a:t>A cup50 clip is one attempt — score its end. An aria episode is 25 attempts — segment first (cup speed relative to the saucer, so head motion cancels), then score each.</a:t>
+            </a:r>
+          </a:p>
+        </p:txBody>
+      </p:sp>
+      <p:sp>
+        <p:nvSpPr>
+          <p:cNvPr id="19" name="Rectangle 18"/>
           <p:cNvSpPr/>
           <p:nvPr/>
         </p:nvSpPr>
@@ -4578,7 +4554,7 @@
       </p:sp>
       <p:sp>
         <p:nvSpPr>
-          <p:cNvPr id="19" name="TextBox 18"/>
+          <p:cNvPr id="20" name="TextBox 19"/>
           <p:cNvSpPr txBox="1"/>
           <p:nvPr/>
         </p:nvSpPr>
@@ -4600,7 +4576,7 @@
           <a:p>
             <a:pPr>
               <a:lnSpc>
-                <a:spcPct val="115000"/>
+                <a:spcPct val="112000"/>
               </a:lnSpc>
             </a:pPr>
             <a:r>
@@ -4616,7 +4592,7 @@
           <a:p>
             <a:pPr>
               <a:lnSpc>
-                <a:spcPct val="115000"/>
+                <a:spcPct val="112000"/>
               </a:lnSpc>
             </a:pPr>
             <a:r>
@@ -4626,14 +4602,14 @@
                 </a:solidFill>
                 <a:latin typeface="Calibri"/>
               </a:rPr>
-              <a:t>Geometric track is CPU — the whole slice in seconds. SAM 3 is text-prompted from the task description, so no per-episode human seeding. VLM is one batched forward pass per sampled frame. A full-dataset sweep is a .map() with per-stage GPUs — many cheap ones for SAM 3, a few big ones for the critic.</a:t>
-            </a:r>
-          </a:p>
-        </p:txBody>
-      </p:sp>
-      <p:sp>
-        <p:nvSpPr>
-          <p:cNvPr id="20" name="TextBox 19"/>
+              <a:t>Geometric track is CPU — the whole slice in seconds. SAM 3 is text-prompted from the task description, so no per-episode human seeding. VLM is one batched forward pass per sampled frame (16/pass, H100): 50 clips × 3 models in minutes. A full-dataset sweep is a .map() with per-stage GPUs.</a:t>
+            </a:r>
+          </a:p>
+        </p:txBody>
+      </p:sp>
+      <p:sp>
+        <p:nvSpPr>
+          <p:cNvPr id="21" name="TextBox 20"/>
           <p:cNvSpPr txBox="1"/>
           <p:nvPr/>
         </p:nvSpPr>
@@ -4655,7 +4631,7 @@
           <a:p>
             <a:pPr>
               <a:lnSpc>
-                <a:spcPct val="115000"/>
+                <a:spcPct val="112000"/>
               </a:lnSpc>
             </a:pPr>
             <a:r>
@@ -4672,7 +4648,7 @@
       </p:sp>
       <p:sp>
         <p:nvSpPr>
-          <p:cNvPr id="21" name="TextBox 20"/>
+          <p:cNvPr id="22" name="TextBox 21"/>
           <p:cNvSpPr txBox="1"/>
           <p:nvPr/>
         </p:nvSpPr>
@@ -4694,7 +4670,7 @@
           <a:p>
             <a:pPr algn="r">
               <a:lnSpc>
-                <a:spcPct val="115000"/>
+                <a:spcPct val="112000"/>
               </a:lnSpc>
             </a:pPr>
             <a:r>

</xml_diff>

<commit_message>
cup50 as the main result; slide with segmentation + meter stills; README with inline GIFs/stills/graphs
Co-Authored-By: Claude Opus 5 (1M context) <noreply@anthropic.com>
</commit_message>
<xml_diff>
--- a/SLIDE.pptx
+++ b/SLIDE.pptx
@@ -3096,7 +3096,7 @@
         </p:nvSpPr>
         <p:spPr>
           <a:xfrm>
-            <a:off x="457200" y="274320"/>
+            <a:off x="457200" y="256032"/>
             <a:ext cx="13716000" cy="640080"/>
           </a:xfrm>
           <a:prstGeom prst="rect">
@@ -3105,14 +3105,14 @@
           <a:noFill/>
         </p:spPr>
         <p:txBody>
-          <a:bodyPr wrap="square" lIns="45720" rIns="45720" tIns="18288" bIns="18288">
+          <a:bodyPr wrap="square" lIns="36576" rIns="36576" tIns="18288" bIns="18288">
             <a:spAutoFit/>
           </a:bodyPr>
           <a:lstStyle/>
           <a:p>
             <a:pPr>
               <a:lnSpc>
-                <a:spcPct val="112000"/>
+                <a:spcPct val="110000"/>
               </a:lnSpc>
             </a:pPr>
             <a:r>
@@ -3125,13 +3125,13 @@
               <a:t>Human Reward Model — Track 3</a:t>
             </a:r>
             <a:r>
-              <a:rPr sz="1600" b="0" i="0">
+              <a:rPr sz="1500" b="0" i="0">
                 <a:solidFill>
                   <a:srgbClr val="555555"/>
                 </a:solidFill>
                 <a:latin typeface="Calibri"/>
               </a:rPr>
-              <a:t>   Does the demo succeed? Ask the VLM's logits, not its words.</a:t>
+              <a:t>   Does the demo succeed? Ask the VLM's logits, not its words — and check it against geometry.</a:t>
             </a:r>
           </a:p>
         </p:txBody>
@@ -3144,8 +3144,8 @@
         </p:nvSpPr>
         <p:spPr>
           <a:xfrm>
-            <a:off x="457200" y="1005840"/>
-            <a:ext cx="6949440" cy="292608"/>
+            <a:off x="457200" y="960120"/>
+            <a:ext cx="7498079" cy="274320"/>
           </a:xfrm>
           <a:prstGeom prst="rect">
             <a:avLst/>
@@ -3153,14 +3153,14 @@
           <a:noFill/>
         </p:spPr>
         <p:txBody>
-          <a:bodyPr wrap="square" lIns="45720" rIns="45720" tIns="18288" bIns="18288">
+          <a:bodyPr wrap="square" lIns="36576" rIns="36576" tIns="18288" bIns="18288">
             <a:spAutoFit/>
           </a:bodyPr>
           <a:lstStyle/>
           <a:p>
             <a:pPr>
               <a:lnSpc>
-                <a:spcPct val="112000"/>
+                <a:spcPct val="110000"/>
               </a:lnSpc>
             </a:pPr>
             <a:r>
@@ -3170,22 +3170,70 @@
                 </a:solidFill>
                 <a:latin typeface="Calibri"/>
               </a:rPr>
-              <a:t>DELIVERABLES — ALL THREE, ALL RUNNING (MODAL RUN)</a:t>
+              <a:t>MAIN RESULT — A FAILURE AUDIT OF 50 HUMAN CUP-ON-SAUCER DEMOS</a:t>
+            </a:r>
+          </a:p>
+        </p:txBody>
+      </p:sp>
+      <p:sp>
+        <p:nvSpPr>
+          <p:cNvPr id="4" name="TextBox 3"/>
+          <p:cNvSpPr txBox="1"/>
+          <p:nvPr/>
+        </p:nvSpPr>
+        <p:spPr>
+          <a:xfrm>
+            <a:off x="457200" y="1243584"/>
+            <a:ext cx="7498079" cy="457200"/>
+          </a:xfrm>
+          <a:prstGeom prst="rect">
+            <a:avLst/>
+          </a:prstGeom>
+          <a:noFill/>
+        </p:spPr>
+        <p:txBody>
+          <a:bodyPr wrap="square" lIns="36576" rIns="36576" tIns="18288" bIns="18288">
+            <a:spAutoFit/>
+          </a:bodyPr>
+          <a:lstStyle/>
+          <a:p>
+            <a:pPr>
+              <a:lnSpc>
+                <a:spcPct val="110000"/>
+              </a:lnSpc>
+            </a:pPr>
+            <a:r>
+              <a:rPr sz="1050" b="1" i="0">
+                <a:solidFill>
+                  <a:srgbClr val="111111"/>
+                </a:solidFill>
+                <a:latin typeface="Calibri"/>
+              </a:rPr>
+              <a:t>Success = the cup ends up on the saucer. </a:t>
+            </a:r>
+            <a:r>
+              <a:rPr sz="1050" b="0" i="0">
+                <a:solidFill>
+                  <a:srgbClr val="555555"/>
+                </a:solidFill>
+                <a:latin typeface="Calibri"/>
+              </a:rPr>
+              <a:t>No labels exist for these clips: four independent signals, every one run on every clip, fused per episode. Zero training, zero new labels, all on Modal.</a:t>
             </a:r>
           </a:p>
         </p:txBody>
       </p:sp>
       <p:graphicFrame>
         <p:nvGraphicFramePr>
-          <p:cNvPr id="4" name="Table 3"/>
+          <p:cNvPr id="5" name="Table 4"/>
           <p:cNvGraphicFramePr>
             <a:graphicFrameLocks noGrp="1"/>
           </p:cNvGraphicFramePr>
           <p:nvPr/>
         </p:nvGraphicFramePr>
         <p:xfrm>
-          <a:off x="457200" y="1298448"/>
-          <a:ext cx="6949440" cy="1024128"/>
+          <a:off x="457200" y="1691640"/>
+          <a:ext cx="7498080" cy="950976"/>
         </p:xfrm>
         <a:graphic>
           <a:graphicData uri="http://schemas.openxmlformats.org/drawingml/2006/table">
@@ -3194,283 +3242,19 @@
                 <a:tableStyleId>{5C22544A-7EE6-4342-B048-85BDC9FD1C3A}</a:tableStyleId>
               </a:tblPr>
               <a:tblGrid>
-                <a:gridCol w="1463040"/>
-                <a:gridCol w="5486400"/>
+                <a:gridCol w="2377440"/>
+                <a:gridCol w="3566160"/>
+                <a:gridCol w="822960"/>
+                <a:gridCol w="731520"/>
               </a:tblGrid>
-              <a:tr h="256032">
+              <a:tr h="237744">
                 <a:tc>
                   <a:txBody>
                     <a:bodyPr/>
                     <a:lstStyle/>
                     <a:p>
                       <a:r>
-                        <a:rPr b="1" sz="950">
-                          <a:solidFill>
-                            <a:srgbClr val="555555"/>
-                          </a:solidFill>
-                        </a:rPr>
-                        <a:t>Track 3 asks for</a:t>
-                      </a:r>
-                    </a:p>
-                  </a:txBody>
-                  <a:tcPr marL="45720" marR="45720" marT="18288" marB="18288">
-                    <a:solidFill>
-                      <a:srgbClr val="F7F9FC"/>
-                    </a:solidFill>
-                  </a:tcPr>
-                </a:tc>
-                <a:tc>
-                  <a:txBody>
-                    <a:bodyPr/>
-                    <a:lstStyle/>
-                    <a:p>
-                      <a:r>
-                        <a:rPr b="1" sz="950">
-                          <a:solidFill>
-                            <a:srgbClr val="555555"/>
-                          </a:solidFill>
-                        </a:rPr>
-                        <a:t>We ship</a:t>
-                      </a:r>
-                    </a:p>
-                  </a:txBody>
-                  <a:tcPr marL="45720" marR="45720" marT="18288" marB="18288">
-                    <a:solidFill>
-                      <a:srgbClr val="F7F9FC"/>
-                    </a:solidFill>
-                  </a:tcPr>
-                </a:tc>
-              </a:tr>
-              <a:tr h="256032">
-                <a:tc>
-                  <a:txBody>
-                    <a:bodyPr/>
-                    <a:lstStyle/>
-                    <a:p>
-                      <a:r>
-                        <a:rPr b="0" sz="1050">
-                          <a:solidFill>
-                            <a:srgbClr val="111111"/>
-                          </a:solidFill>
-                        </a:rPr>
-                        <a:t>Tagged episodes</a:t>
-                      </a:r>
-                    </a:p>
-                  </a:txBody>
-                  <a:tcPr marL="45720" marR="45720" marT="18288" marB="18288">
-                    <a:solidFill>
-                      <a:srgbClr val="FFFFFF"/>
-                    </a:solidFill>
-                  </a:tcPr>
-                </a:tc>
-                <a:tc>
-                  <a:txBody>
-                    <a:bodyPr/>
-                    <a:lstStyle/>
-                    <a:p>
-                      <a:r>
-                        <a:rPr b="0" sz="1050">
-                          <a:solidFill>
-                            <a:srgbClr val="111111"/>
-                          </a:solidFill>
-                        </a:rPr>
-                        <a:t>success/failure per episode from per-frame p(cup on saucer) read from Qwen3-VL / Cosmos-Reason2 / PaliGemma logits</a:t>
-                      </a:r>
-                    </a:p>
-                  </a:txBody>
-                  <a:tcPr marL="45720" marR="45720" marT="18288" marB="18288">
-                    <a:solidFill>
-                      <a:srgbClr val="FFFFFF"/>
-                    </a:solidFill>
-                  </a:tcPr>
-                </a:tc>
-              </a:tr>
-              <a:tr h="256032">
-                <a:tc>
-                  <a:txBody>
-                    <a:bodyPr/>
-                    <a:lstStyle/>
-                    <a:p>
-                      <a:r>
-                        <a:rPr b="0" sz="1050">
-                          <a:solidFill>
-                            <a:srgbClr val="111111"/>
-                          </a:solidFill>
-                        </a:rPr>
-                        <a:t>Confidence meter</a:t>
-                      </a:r>
-                    </a:p>
-                  </a:txBody>
-                  <a:tcPr marL="45720" marR="45720" marT="18288" marB="18288">
-                    <a:solidFill>
-                      <a:srgbClr val="FFFFFF"/>
-                    </a:solidFill>
-                  </a:tcPr>
-                </a:tc>
-                <a:tc>
-                  <a:txBody>
-                    <a:bodyPr/>
-                    <a:lstStyle/>
-                    <a:p>
-                      <a:r>
-                        <a:rPr b="0" sz="1050">
-                          <a:solidFill>
-                            <a:srgbClr val="111111"/>
-                          </a:solidFill>
-                        </a:rPr>
-                        <a:t>the p(done) curve itself, rendered as a video per episode (bar + sparkline)</a:t>
-                      </a:r>
-                    </a:p>
-                  </a:txBody>
-                  <a:tcPr marL="45720" marR="45720" marT="18288" marB="18288">
-                    <a:solidFill>
-                      <a:srgbClr val="FFFFFF"/>
-                    </a:solidFill>
-                  </a:tcPr>
-                </a:tc>
-              </a:tr>
-              <a:tr h="256032">
-                <a:tc>
-                  <a:txBody>
-                    <a:bodyPr/>
-                    <a:lstStyle/>
-                    <a:p>
-                      <a:r>
-                        <a:rPr b="0" sz="1050">
-                          <a:solidFill>
-                            <a:srgbClr val="111111"/>
-                          </a:solidFill>
-                        </a:rPr>
-                        <a:t>Prevalence audit</a:t>
-                      </a:r>
-                    </a:p>
-                  </a:txBody>
-                  <a:tcPr marL="45720" marR="45720" marT="18288" marB="18288">
-                    <a:solidFill>
-                      <a:srgbClr val="FFFFFF"/>
-                    </a:solidFill>
-                  </a:tcPr>
-                </a:tc>
-                <a:tc>
-                  <a:txBody>
-                    <a:bodyPr/>
-                    <a:lstStyle/>
-                    <a:p>
-                      <a:r>
-                        <a:rPr b="0" sz="1050">
-                          <a:solidFill>
-                            <a:srgbClr val="111111"/>
-                          </a:solidFill>
-                        </a:rPr>
-                        <a:t>SAM 3 + 3 VLMs on all 50 human clips → 30% failure (27/50 unanimous)</a:t>
-                      </a:r>
-                    </a:p>
-                  </a:txBody>
-                  <a:tcPr marL="45720" marR="45720" marT="18288" marB="18288">
-                    <a:solidFill>
-                      <a:srgbClr val="FFFFFF"/>
-                    </a:solidFill>
-                  </a:tcPr>
-                </a:tc>
-              </a:tr>
-            </a:tbl>
-          </a:graphicData>
-        </a:graphic>
-      </p:graphicFrame>
-      <p:sp>
-        <p:nvSpPr>
-          <p:cNvPr id="5" name="TextBox 4"/>
-          <p:cNvSpPr txBox="1"/>
-          <p:nvPr/>
-        </p:nvSpPr>
-        <p:spPr>
-          <a:xfrm>
-            <a:off x="457200" y="2788920"/>
-            <a:ext cx="6949440" cy="292608"/>
-          </a:xfrm>
-          <a:prstGeom prst="rect">
-            <a:avLst/>
-          </a:prstGeom>
-          <a:noFill/>
-        </p:spPr>
-        <p:txBody>
-          <a:bodyPr wrap="square" lIns="45720" rIns="45720" tIns="18288" bIns="18288">
-            <a:spAutoFit/>
-          </a:bodyPr>
-          <a:lstStyle/>
-          <a:p>
-            <a:pPr>
-              <a:lnSpc>
-                <a:spcPct val="112000"/>
-              </a:lnSpc>
-            </a:pPr>
-            <a:r>
-              <a:rPr sz="1250" b="1" i="0">
-                <a:solidFill>
-                  <a:srgbClr val="1982C4"/>
-                </a:solidFill>
-                <a:latin typeface="Calibri"/>
-              </a:rPr>
-              <a:t>LABELLED ROBOT SLICE — 20 EPISODES, 10 / 10</a:t>
-            </a:r>
-          </a:p>
-        </p:txBody>
-      </p:sp>
-      <p:pic>
-        <p:nvPicPr>
-          <p:cNvPr id="6" name="Picture 5" descr="eva_roc.png"/>
-          <p:cNvPicPr>
-            <a:picLocks noChangeAspect="1"/>
-          </p:cNvPicPr>
-          <p:nvPr/>
-        </p:nvPicPr>
-        <p:blipFill>
-          <a:blip r:embed="rId2"/>
-          <a:stretch>
-            <a:fillRect/>
-          </a:stretch>
-        </p:blipFill>
-        <p:spPr>
-          <a:xfrm>
-            <a:off x="457200" y="3108960"/>
-            <a:ext cx="2011680" cy="2011680"/>
-          </a:xfrm>
-          <a:prstGeom prst="rect">
-            <a:avLst/>
-          </a:prstGeom>
-        </p:spPr>
-      </p:pic>
-      <p:graphicFrame>
-        <p:nvGraphicFramePr>
-          <p:cNvPr id="7" name="Table 6"/>
-          <p:cNvGraphicFramePr>
-            <a:graphicFrameLocks noGrp="1"/>
-          </p:cNvGraphicFramePr>
-          <p:nvPr/>
-        </p:nvGraphicFramePr>
-        <p:xfrm>
-          <a:off x="2651760" y="3154680"/>
-          <a:ext cx="4754880" cy="1024128"/>
-        </p:xfrm>
-        <a:graphic>
-          <a:graphicData uri="http://schemas.openxmlformats.org/drawingml/2006/table">
-            <a:tbl>
-              <a:tblPr firstRow="1" bandRow="1">
-                <a:tableStyleId>{5C22544A-7EE6-4342-B048-85BDC9FD1C3A}</a:tableStyleId>
-              </a:tblPr>
-              <a:tblGrid>
-                <a:gridCol w="3108960"/>
-                <a:gridCol w="731520"/>
-                <a:gridCol w="914400"/>
-              </a:tblGrid>
-              <a:tr h="256032">
-                <a:tc>
-                  <a:txBody>
-                    <a:bodyPr/>
-                    <a:lstStyle/>
-                    <a:p>
-                      <a:r>
-                        <a:rPr b="1" sz="950">
+                        <a:rPr b="1" sz="900">
                           <a:solidFill>
                             <a:srgbClr val="555555"/>
                           </a:solidFill>
@@ -3491,12 +3275,12 @@
                     <a:lstStyle/>
                     <a:p>
                       <a:r>
-                        <a:rPr b="1" sz="950">
+                        <a:rPr b="1" sz="900">
                           <a:solidFill>
                             <a:srgbClr val="555555"/>
                           </a:solidFill>
                         </a:rPr>
-                        <a:t>Acc</a:t>
+                        <a:t>How</a:t>
                       </a:r>
                     </a:p>
                   </a:txBody>
@@ -3512,7 +3296,786 @@
                     <a:lstStyle/>
                     <a:p>
                       <a:r>
-                        <a:rPr b="1" sz="950">
+                        <a:rPr b="1" sz="900">
+                          <a:solidFill>
+                            <a:srgbClr val="555555"/>
+                          </a:solidFill>
+                        </a:rPr>
+                        <a:t>Success</a:t>
+                      </a:r>
+                    </a:p>
+                  </a:txBody>
+                  <a:tcPr marL="45720" marR="45720" marT="18288" marB="18288">
+                    <a:solidFill>
+                      <a:srgbClr val="F7F9FC"/>
+                    </a:solidFill>
+                  </a:tcPr>
+                </a:tc>
+                <a:tc>
+                  <a:txBody>
+                    <a:bodyPr/>
+                    <a:lstStyle/>
+                    <a:p>
+                      <a:r>
+                        <a:rPr b="1" sz="900">
+                          <a:solidFill>
+                            <a:srgbClr val="555555"/>
+                          </a:solidFill>
+                        </a:rPr>
+                        <a:t>Failure prev.</a:t>
+                      </a:r>
+                    </a:p>
+                  </a:txBody>
+                  <a:tcPr marL="45720" marR="45720" marT="18288" marB="18288">
+                    <a:solidFill>
+                      <a:srgbClr val="F7F9FC"/>
+                    </a:solidFill>
+                  </a:tcPr>
+                </a:tc>
+              </a:tr>
+              <a:tr h="237744">
+                <a:tc>
+                  <a:txBody>
+                    <a:bodyPr/>
+                    <a:lstStyle/>
+                    <a:p>
+                      <a:r>
+                        <a:rPr b="0" sz="1000">
+                          <a:solidFill>
+                            <a:srgbClr val="111111"/>
+                          </a:solidFill>
+                        </a:rPr>
+                        <a:t>SAM 3 geometry</a:t>
+                      </a:r>
+                    </a:p>
+                  </a:txBody>
+                  <a:tcPr marL="45720" marR="45720" marT="18288" marB="18288">
+                    <a:solidFill>
+                      <a:srgbClr val="FFFFFF"/>
+                    </a:solidFill>
+                  </a:tcPr>
+                </a:tc>
+                <a:tc>
+                  <a:txBody>
+                    <a:bodyPr/>
+                    <a:lstStyle/>
+                    <a:p>
+                      <a:r>
+                        <a:rPr b="0" sz="1000">
+                          <a:solidFill>
+                            <a:srgbClr val="111111"/>
+                          </a:solidFill>
+                        </a:rPr>
+                        <a:t>text-prompted cup/saucer masks; cup centroid in saucer box at the end</a:t>
+                      </a:r>
+                    </a:p>
+                  </a:txBody>
+                  <a:tcPr marL="45720" marR="45720" marT="18288" marB="18288">
+                    <a:solidFill>
+                      <a:srgbClr val="FFFFFF"/>
+                    </a:solidFill>
+                  </a:tcPr>
+                </a:tc>
+                <a:tc>
+                  <a:txBody>
+                    <a:bodyPr/>
+                    <a:lstStyle/>
+                    <a:p>
+                      <a:r>
+                        <a:rPr b="0" sz="1000">
+                          <a:solidFill>
+                            <a:srgbClr val="111111"/>
+                          </a:solidFill>
+                        </a:rPr>
+                        <a:t>36/50</a:t>
+                      </a:r>
+                    </a:p>
+                  </a:txBody>
+                  <a:tcPr marL="45720" marR="45720" marT="18288" marB="18288">
+                    <a:solidFill>
+                      <a:srgbClr val="FFFFFF"/>
+                    </a:solidFill>
+                  </a:tcPr>
+                </a:tc>
+                <a:tc>
+                  <a:txBody>
+                    <a:bodyPr/>
+                    <a:lstStyle/>
+                    <a:p>
+                      <a:r>
+                        <a:rPr b="0" sz="1000">
+                          <a:solidFill>
+                            <a:srgbClr val="111111"/>
+                          </a:solidFill>
+                        </a:rPr>
+                        <a:t>28%</a:t>
+                      </a:r>
+                    </a:p>
+                  </a:txBody>
+                  <a:tcPr marL="45720" marR="45720" marT="18288" marB="18288">
+                    <a:solidFill>
+                      <a:srgbClr val="FFFFFF"/>
+                    </a:solidFill>
+                  </a:tcPr>
+                </a:tc>
+              </a:tr>
+              <a:tr h="237744">
+                <a:tc>
+                  <a:txBody>
+                    <a:bodyPr/>
+                    <a:lstStyle/>
+                    <a:p>
+                      <a:r>
+                        <a:rPr b="0" sz="1000">
+                          <a:solidFill>
+                            <a:srgbClr val="111111"/>
+                          </a:solidFill>
+                        </a:rPr>
+                        <a:t>Qwen3-VL-8B · PaliGemma2-3B · Cosmos-R2-8B</a:t>
+                      </a:r>
+                    </a:p>
+                  </a:txBody>
+                  <a:tcPr marL="45720" marR="45720" marT="18288" marB="18288">
+                    <a:solidFill>
+                      <a:srgbClr val="FFFFFF"/>
+                    </a:solidFill>
+                  </a:tcPr>
+                </a:tc>
+                <a:tc>
+                  <a:txBody>
+                    <a:bodyPr/>
+                    <a:lstStyle/>
+                    <a:p>
+                      <a:r>
+                        <a:rPr b="0" sz="1000">
+                          <a:solidFill>
+                            <a:srgbClr val="111111"/>
+                          </a:solidFill>
+                        </a:rPr>
+                        <a:t>p("Yes") from logits to "is the cup resting on the saucer?", last quarter</a:t>
+                      </a:r>
+                    </a:p>
+                  </a:txBody>
+                  <a:tcPr marL="45720" marR="45720" marT="18288" marB="18288">
+                    <a:solidFill>
+                      <a:srgbClr val="FFFFFF"/>
+                    </a:solidFill>
+                  </a:tcPr>
+                </a:tc>
+                <a:tc>
+                  <a:txBody>
+                    <a:bodyPr/>
+                    <a:lstStyle/>
+                    <a:p>
+                      <a:r>
+                        <a:rPr b="0" sz="1000">
+                          <a:solidFill>
+                            <a:srgbClr val="111111"/>
+                          </a:solidFill>
+                        </a:rPr>
+                        <a:t>39 · 42 · 34</a:t>
+                      </a:r>
+                    </a:p>
+                  </a:txBody>
+                  <a:tcPr marL="45720" marR="45720" marT="18288" marB="18288">
+                    <a:solidFill>
+                      <a:srgbClr val="FFFFFF"/>
+                    </a:solidFill>
+                  </a:tcPr>
+                </a:tc>
+                <a:tc>
+                  <a:txBody>
+                    <a:bodyPr/>
+                    <a:lstStyle/>
+                    <a:p>
+                      <a:r>
+                        <a:rPr b="0" sz="1000">
+                          <a:solidFill>
+                            <a:srgbClr val="111111"/>
+                          </a:solidFill>
+                        </a:rPr>
+                        <a:t>22 · 16 · 32%</a:t>
+                      </a:r>
+                    </a:p>
+                  </a:txBody>
+                  <a:tcPr marL="45720" marR="45720" marT="18288" marB="18288">
+                    <a:solidFill>
+                      <a:srgbClr val="FFFFFF"/>
+                    </a:solidFill>
+                  </a:tcPr>
+                </a:tc>
+              </a:tr>
+              <a:tr h="237744">
+                <a:tc>
+                  <a:txBody>
+                    <a:bodyPr/>
+                    <a:lstStyle/>
+                    <a:p>
+                      <a:r>
+                        <a:rPr b="1" sz="1000">
+                          <a:solidFill>
+                            <a:srgbClr val="111111"/>
+                          </a:solidFill>
+                        </a:rPr>
+                        <a:t>Fused = mean(SEG, mean of VLMs)</a:t>
+                      </a:r>
+                    </a:p>
+                  </a:txBody>
+                  <a:tcPr marL="45720" marR="45720" marT="18288" marB="18288">
+                    <a:solidFill>
+                      <a:srgbClr val="FFFFFF"/>
+                    </a:solidFill>
+                  </a:tcPr>
+                </a:tc>
+                <a:tc>
+                  <a:txBody>
+                    <a:bodyPr/>
+                    <a:lstStyle/>
+                    <a:p>
+                      <a:r>
+                        <a:rPr b="0" sz="1000">
+                          <a:solidFill>
+                            <a:srgbClr val="111111"/>
+                          </a:solidFill>
+                        </a:rPr>
+                        <a:t>geometry and language weighted equally</a:t>
+                      </a:r>
+                    </a:p>
+                  </a:txBody>
+                  <a:tcPr marL="45720" marR="45720" marT="18288" marB="18288">
+                    <a:solidFill>
+                      <a:srgbClr val="FFFFFF"/>
+                    </a:solidFill>
+                  </a:tcPr>
+                </a:tc>
+                <a:tc>
+                  <a:txBody>
+                    <a:bodyPr/>
+                    <a:lstStyle/>
+                    <a:p>
+                      <a:r>
+                        <a:rPr b="1" sz="1000">
+                          <a:solidFill>
+                            <a:srgbClr val="111111"/>
+                          </a:solidFill>
+                        </a:rPr>
+                        <a:t>35/50</a:t>
+                      </a:r>
+                    </a:p>
+                  </a:txBody>
+                  <a:tcPr marL="45720" marR="45720" marT="18288" marB="18288">
+                    <a:solidFill>
+                      <a:srgbClr val="FFFFFF"/>
+                    </a:solidFill>
+                  </a:tcPr>
+                </a:tc>
+                <a:tc>
+                  <a:txBody>
+                    <a:bodyPr/>
+                    <a:lstStyle/>
+                    <a:p>
+                      <a:r>
+                        <a:rPr b="1" sz="1000">
+                          <a:solidFill>
+                            <a:srgbClr val="111111"/>
+                          </a:solidFill>
+                        </a:rPr>
+                        <a:t>30%</a:t>
+                      </a:r>
+                    </a:p>
+                  </a:txBody>
+                  <a:tcPr marL="45720" marR="45720" marT="18288" marB="18288">
+                    <a:solidFill>
+                      <a:srgbClr val="FFFFFF"/>
+                    </a:solidFill>
+                  </a:tcPr>
+                </a:tc>
+              </a:tr>
+            </a:tbl>
+          </a:graphicData>
+        </a:graphic>
+      </p:graphicFrame>
+      <p:sp>
+        <p:nvSpPr>
+          <p:cNvPr id="6" name="TextBox 5"/>
+          <p:cNvSpPr txBox="1"/>
+          <p:nvPr/>
+        </p:nvSpPr>
+        <p:spPr>
+          <a:xfrm>
+            <a:off x="457200" y="2743200"/>
+            <a:ext cx="7498079" cy="320040"/>
+          </a:xfrm>
+          <a:prstGeom prst="rect">
+            <a:avLst/>
+          </a:prstGeom>
+          <a:noFill/>
+        </p:spPr>
+        <p:txBody>
+          <a:bodyPr wrap="square" lIns="36576" rIns="36576" tIns="18288" bIns="18288">
+            <a:spAutoFit/>
+          </a:bodyPr>
+          <a:lstStyle/>
+          <a:p>
+            <a:pPr>
+              <a:lnSpc>
+                <a:spcPct val="110000"/>
+              </a:lnSpc>
+            </a:pPr>
+            <a:r>
+              <a:rPr sz="1050" b="1" i="0">
+                <a:solidFill>
+                  <a:srgbClr val="111111"/>
+                </a:solidFill>
+                <a:latin typeface="Calibri"/>
+              </a:rPr>
+              <a:t>27/50 unanimous</a:t>
+            </a:r>
+            <a:r>
+              <a:rPr sz="1050" b="0" i="0">
+                <a:solidFill>
+                  <a:srgbClr val="555555"/>
+                </a:solidFill>
+                <a:latin typeface="Calibri"/>
+              </a:rPr>
+              <a:t> across all four signals · 37/50 with ≥3 of 4 · 6 split 2–2. Geometry (28%) and language (30%) land on the same prevalence.</a:t>
+            </a:r>
+          </a:p>
+        </p:txBody>
+      </p:sp>
+      <p:pic>
+        <p:nvPicPr>
+          <p:cNvPr id="7" name="Picture 6" descr="unanimous_success_692e98927641010d04354574_end.jpg"/>
+          <p:cNvPicPr>
+            <a:picLocks noChangeAspect="1"/>
+          </p:cNvPicPr>
+          <p:nvPr/>
+        </p:nvPicPr>
+        <p:blipFill>
+          <a:blip r:embed="rId2"/>
+          <a:stretch>
+            <a:fillRect/>
+          </a:stretch>
+        </p:blipFill>
+        <p:spPr>
+          <a:xfrm>
+            <a:off x="457200" y="3108960"/>
+            <a:ext cx="1810512" cy="1018413"/>
+          </a:xfrm>
+          <a:prstGeom prst="rect">
+            <a:avLst/>
+          </a:prstGeom>
+        </p:spPr>
+      </p:pic>
+      <p:sp>
+        <p:nvSpPr>
+          <p:cNvPr id="8" name="TextBox 7"/>
+          <p:cNvSpPr txBox="1"/>
+          <p:nvPr/>
+        </p:nvSpPr>
+        <p:spPr>
+          <a:xfrm>
+            <a:off x="457200" y="4480560"/>
+            <a:ext cx="1810512" cy="548640"/>
+          </a:xfrm>
+          <a:prstGeom prst="rect">
+            <a:avLst/>
+          </a:prstGeom>
+          <a:noFill/>
+        </p:spPr>
+        <p:txBody>
+          <a:bodyPr wrap="square" lIns="36576" rIns="36576" tIns="18288" bIns="18288">
+            <a:spAutoFit/>
+          </a:bodyPr>
+          <a:lstStyle/>
+          <a:p>
+            <a:pPr>
+              <a:lnSpc>
+                <a:spcPct val="110000"/>
+              </a:lnSpc>
+            </a:pPr>
+            <a:r>
+              <a:rPr sz="850" b="0" i="0">
+                <a:solidFill>
+                  <a:srgbClr val="555555"/>
+                </a:solidFill>
+                <a:latin typeface="Calibri"/>
+              </a:rPr>
+              <a:t>✅ unanimous — SEG 1.00 · VLMs .96/.79/1.00. SAM 3 tracks hand, cup, saucer at 10 fps.</a:t>
+            </a:r>
+          </a:p>
+        </p:txBody>
+      </p:sp>
+      <p:pic>
+        <p:nvPicPr>
+          <p:cNvPr id="9" name="Picture 8" descr="unanimous_failure_2026-01-11-23-11-22-998000_end.jpg"/>
+          <p:cNvPicPr>
+            <a:picLocks noChangeAspect="1"/>
+          </p:cNvPicPr>
+          <p:nvPr/>
+        </p:nvPicPr>
+        <p:blipFill>
+          <a:blip r:embed="rId3"/>
+          <a:stretch>
+            <a:fillRect/>
+          </a:stretch>
+        </p:blipFill>
+        <p:spPr>
+          <a:xfrm>
+            <a:off x="2359152" y="3108960"/>
+            <a:ext cx="1810512" cy="1357884"/>
+          </a:xfrm>
+          <a:prstGeom prst="rect">
+            <a:avLst/>
+          </a:prstGeom>
+        </p:spPr>
+      </p:pic>
+      <p:sp>
+        <p:nvSpPr>
+          <p:cNvPr id="10" name="TextBox 9"/>
+          <p:cNvSpPr txBox="1"/>
+          <p:nvPr/>
+        </p:nvSpPr>
+        <p:spPr>
+          <a:xfrm>
+            <a:off x="2359152" y="4480560"/>
+            <a:ext cx="1810512" cy="548640"/>
+          </a:xfrm>
+          <a:prstGeom prst="rect">
+            <a:avLst/>
+          </a:prstGeom>
+          <a:noFill/>
+        </p:spPr>
+        <p:txBody>
+          <a:bodyPr wrap="square" lIns="36576" rIns="36576" tIns="18288" bIns="18288">
+            <a:spAutoFit/>
+          </a:bodyPr>
+          <a:lstStyle/>
+          <a:p>
+            <a:pPr>
+              <a:lnSpc>
+                <a:spcPct val="110000"/>
+              </a:lnSpc>
+            </a:pPr>
+            <a:r>
+              <a:rPr sz="850" b="0" i="0">
+                <a:solidFill>
+                  <a:srgbClr val="555555"/>
+                </a:solidFill>
+                <a:latin typeface="Calibri"/>
+              </a:rPr>
+              <a:t>❌ unanimous — SEG 0.00 · VLMs .00/.07/.00</a:t>
+            </a:r>
+          </a:p>
+        </p:txBody>
+      </p:sp>
+      <p:pic>
+        <p:nvPicPr>
+          <p:cNvPr id="11" name="Picture 10" descr="disputed_seg_yes_vlm_split_692ea3beffdc0ca6345c4246_end.jpg"/>
+          <p:cNvPicPr>
+            <a:picLocks noChangeAspect="1"/>
+          </p:cNvPicPr>
+          <p:nvPr/>
+        </p:nvPicPr>
+        <p:blipFill>
+          <a:blip r:embed="rId4"/>
+          <a:stretch>
+            <a:fillRect/>
+          </a:stretch>
+        </p:blipFill>
+        <p:spPr>
+          <a:xfrm>
+            <a:off x="4261104" y="3108960"/>
+            <a:ext cx="1810512" cy="1018413"/>
+          </a:xfrm>
+          <a:prstGeom prst="rect">
+            <a:avLst/>
+          </a:prstGeom>
+        </p:spPr>
+      </p:pic>
+      <p:sp>
+        <p:nvSpPr>
+          <p:cNvPr id="12" name="TextBox 11"/>
+          <p:cNvSpPr txBox="1"/>
+          <p:nvPr/>
+        </p:nvSpPr>
+        <p:spPr>
+          <a:xfrm>
+            <a:off x="4261104" y="4480560"/>
+            <a:ext cx="1810512" cy="548640"/>
+          </a:xfrm>
+          <a:prstGeom prst="rect">
+            <a:avLst/>
+          </a:prstGeom>
+          <a:noFill/>
+        </p:spPr>
+        <p:txBody>
+          <a:bodyPr wrap="square" lIns="36576" rIns="36576" tIns="18288" bIns="18288">
+            <a:spAutoFit/>
+          </a:bodyPr>
+          <a:lstStyle/>
+          <a:p>
+            <a:pPr>
+              <a:lnSpc>
+                <a:spcPct val="110000"/>
+              </a:lnSpc>
+            </a:pPr>
+            <a:r>
+              <a:rPr sz="850" b="0" i="0">
+                <a:solidFill>
+                  <a:srgbClr val="555555"/>
+                </a:solidFill>
+                <a:latin typeface="Calibri"/>
+              </a:rPr>
+              <a:t>disputed — SEG 1.00, VLMs .32/.58/.00 → geometry carries it ✅</a:t>
+            </a:r>
+          </a:p>
+        </p:txBody>
+      </p:sp>
+      <p:pic>
+        <p:nvPicPr>
+          <p:cNvPr id="13" name="Picture 12" descr="cup50_qwen_692e98927641010d04354574_meter_end.jpg"/>
+          <p:cNvPicPr>
+            <a:picLocks noChangeAspect="1"/>
+          </p:cNvPicPr>
+          <p:nvPr/>
+        </p:nvPicPr>
+        <p:blipFill>
+          <a:blip r:embed="rId5"/>
+          <a:stretch>
+            <a:fillRect/>
+          </a:stretch>
+        </p:blipFill>
+        <p:spPr>
+          <a:xfrm>
+            <a:off x="6163056" y="3108960"/>
+            <a:ext cx="1810512" cy="1199464"/>
+          </a:xfrm>
+          <a:prstGeom prst="rect">
+            <a:avLst/>
+          </a:prstGeom>
+        </p:spPr>
+      </p:pic>
+      <p:sp>
+        <p:nvSpPr>
+          <p:cNvPr id="14" name="TextBox 13"/>
+          <p:cNvSpPr txBox="1"/>
+          <p:nvPr/>
+        </p:nvSpPr>
+        <p:spPr>
+          <a:xfrm>
+            <a:off x="6163056" y="4480560"/>
+            <a:ext cx="1810512" cy="548640"/>
+          </a:xfrm>
+          <a:prstGeom prst="rect">
+            <a:avLst/>
+          </a:prstGeom>
+          <a:noFill/>
+        </p:spPr>
+        <p:txBody>
+          <a:bodyPr wrap="square" lIns="36576" rIns="36576" tIns="18288" bIns="18288">
+            <a:spAutoFit/>
+          </a:bodyPr>
+          <a:lstStyle/>
+          <a:p>
+            <a:pPr>
+              <a:lnSpc>
+                <a:spcPct val="110000"/>
+              </a:lnSpc>
+            </a:pPr>
+            <a:r>
+              <a:rPr sz="850" b="0" i="0">
+                <a:solidFill>
+                  <a:srgbClr val="555555"/>
+                </a:solidFill>
+                <a:latin typeface="Calibri"/>
+              </a:rPr>
+              <a:t>the confidence meter: p(cup on saucer) per frame from Qwen logits, bar + sparkline</a:t>
+            </a:r>
+          </a:p>
+        </p:txBody>
+      </p:sp>
+      <p:sp>
+        <p:nvSpPr>
+          <p:cNvPr id="15" name="Rectangle 14"/>
+          <p:cNvSpPr/>
+          <p:nvPr/>
+        </p:nvSpPr>
+        <p:spPr>
+          <a:xfrm>
+            <a:off x="457200" y="5074920"/>
+            <a:ext cx="3657600" cy="2423160"/>
+          </a:xfrm>
+          <a:prstGeom prst="rect">
+            <a:avLst/>
+          </a:prstGeom>
+          <a:solidFill>
+            <a:srgbClr val="FFFFFF"/>
+          </a:solidFill>
+          <a:ln>
+            <a:solidFill>
+              <a:srgbClr val="E6E6E6"/>
+            </a:solidFill>
+          </a:ln>
+        </p:spPr>
+        <p:style>
+          <a:lnRef idx="1">
+            <a:schemeClr val="accent1"/>
+          </a:lnRef>
+          <a:fillRef idx="3">
+            <a:schemeClr val="accent1"/>
+          </a:fillRef>
+          <a:effectRef idx="2">
+            <a:schemeClr val="accent1"/>
+          </a:effectRef>
+          <a:fontRef idx="minor">
+            <a:schemeClr val="lt1"/>
+          </a:fontRef>
+        </p:style>
+        <p:txBody>
+          <a:bodyPr rtlCol="0" anchor="ctr"/>
+          <a:lstStyle/>
+          <a:p>
+            <a:pPr algn="ctr"/>
+          </a:p>
+        </p:txBody>
+      </p:sp>
+      <p:sp>
+        <p:nvSpPr>
+          <p:cNvPr id="16" name="TextBox 15"/>
+          <p:cNvSpPr txBox="1"/>
+          <p:nvPr/>
+        </p:nvSpPr>
+        <p:spPr>
+          <a:xfrm>
+            <a:off x="548640" y="5120640"/>
+            <a:ext cx="3566160" cy="274320"/>
+          </a:xfrm>
+          <a:prstGeom prst="rect">
+            <a:avLst/>
+          </a:prstGeom>
+          <a:noFill/>
+        </p:spPr>
+        <p:txBody>
+          <a:bodyPr wrap="square" lIns="36576" rIns="36576" tIns="18288" bIns="18288">
+            <a:spAutoFit/>
+          </a:bodyPr>
+          <a:lstStyle/>
+          <a:p>
+            <a:pPr>
+              <a:lnSpc>
+                <a:spcPct val="110000"/>
+              </a:lnSpc>
+            </a:pPr>
+            <a:r>
+              <a:rPr sz="950" b="1" i="0">
+                <a:solidFill>
+                  <a:srgbClr val="1982C4"/>
+                </a:solidFill>
+                <a:latin typeface="Calibri"/>
+              </a:rPr>
+              <a:t>SIDE EXPERIMENT · LABELLED ROBOT SLICE (VALIDATION)</a:t>
+            </a:r>
+          </a:p>
+        </p:txBody>
+      </p:sp>
+      <p:pic>
+        <p:nvPicPr>
+          <p:cNvPr id="17" name="Picture 16" descr="eva_roc.png"/>
+          <p:cNvPicPr>
+            <a:picLocks noChangeAspect="1"/>
+          </p:cNvPicPr>
+          <p:nvPr/>
+        </p:nvPicPr>
+        <p:blipFill>
+          <a:blip r:embed="rId6"/>
+          <a:stretch>
+            <a:fillRect/>
+          </a:stretch>
+        </p:blipFill>
+        <p:spPr>
+          <a:xfrm>
+            <a:off x="548640" y="5440680"/>
+            <a:ext cx="1325880" cy="1325880"/>
+          </a:xfrm>
+          <a:prstGeom prst="rect">
+            <a:avLst/>
+          </a:prstGeom>
+        </p:spPr>
+      </p:pic>
+      <p:graphicFrame>
+        <p:nvGraphicFramePr>
+          <p:cNvPr id="18" name="Table 17"/>
+          <p:cNvGraphicFramePr>
+            <a:graphicFrameLocks noGrp="1"/>
+          </p:cNvGraphicFramePr>
+          <p:nvPr/>
+        </p:nvGraphicFramePr>
+        <p:xfrm>
+          <a:off x="1965960" y="5440680"/>
+          <a:ext cx="2103120" cy="950976"/>
+        </p:xfrm>
+        <a:graphic>
+          <a:graphicData uri="http://schemas.openxmlformats.org/drawingml/2006/table">
+            <a:tbl>
+              <a:tblPr firstRow="1" bandRow="1">
+                <a:tableStyleId>{5C22544A-7EE6-4342-B048-85BDC9FD1C3A}</a:tableStyleId>
+              </a:tblPr>
+              <a:tblGrid>
+                <a:gridCol w="1097280"/>
+                <a:gridCol w="457200"/>
+                <a:gridCol w="548640"/>
+              </a:tblGrid>
+              <a:tr h="237744">
+                <a:tc>
+                  <a:txBody>
+                    <a:bodyPr/>
+                    <a:lstStyle/>
+                    <a:p>
+                      <a:r>
+                        <a:rPr b="1" sz="750">
+                          <a:solidFill>
+                            <a:srgbClr val="555555"/>
+                          </a:solidFill>
+                        </a:rPr>
+                        <a:t>eva 10/10</a:t>
+                      </a:r>
+                    </a:p>
+                  </a:txBody>
+                  <a:tcPr marL="45720" marR="45720" marT="18288" marB="18288">
+                    <a:solidFill>
+                      <a:srgbClr val="F7F9FC"/>
+                    </a:solidFill>
+                  </a:tcPr>
+                </a:tc>
+                <a:tc>
+                  <a:txBody>
+                    <a:bodyPr/>
+                    <a:lstStyle/>
+                    <a:p>
+                      <a:r>
+                        <a:rPr b="1" sz="750">
+                          <a:solidFill>
+                            <a:srgbClr val="555555"/>
+                          </a:solidFill>
+                        </a:rPr>
+                        <a:t>acc</a:t>
+                      </a:r>
+                    </a:p>
+                  </a:txBody>
+                  <a:tcPr marL="45720" marR="45720" marT="18288" marB="18288">
+                    <a:solidFill>
+                      <a:srgbClr val="F7F9FC"/>
+                    </a:solidFill>
+                  </a:tcPr>
+                </a:tc>
+                <a:tc>
+                  <a:txBody>
+                    <a:bodyPr/>
+                    <a:lstStyle/>
+                    <a:p>
+                      <a:r>
+                        <a:rPr b="1" sz="750">
                           <a:solidFill>
                             <a:srgbClr val="555555"/>
                           </a:solidFill>
@@ -3528,19 +4091,19 @@
                   </a:tcPr>
                 </a:tc>
               </a:tr>
-              <a:tr h="256032">
+              <a:tr h="237744">
                 <a:tc>
                   <a:txBody>
                     <a:bodyPr/>
                     <a:lstStyle/>
                     <a:p>
                       <a:r>
-                        <a:rPr b="0" sz="1050">
+                        <a:rPr b="0" sz="850">
                           <a:solidFill>
                             <a:srgbClr val="111111"/>
                           </a:solidFill>
                         </a:rPr>
-                        <a:t>VLM p(done), last quarter (Qwen3-VL-8B)</a:t>
+                        <a:t>VLM p(done)</a:t>
                       </a:r>
                     </a:p>
                   </a:txBody>
@@ -3556,7 +4119,7 @@
                     <a:lstStyle/>
                     <a:p>
                       <a:r>
-                        <a:rPr b="0" sz="1050">
+                        <a:rPr b="0" sz="850">
                           <a:solidFill>
                             <a:srgbClr val="111111"/>
                           </a:solidFill>
@@ -3577,7 +4140,7 @@
                     <a:lstStyle/>
                     <a:p>
                       <a:r>
-                        <a:rPr b="1" sz="1050">
+                        <a:rPr b="1" sz="850">
                           <a:solidFill>
                             <a:srgbClr val="111111"/>
                           </a:solidFill>
@@ -3593,14 +4156,14 @@
                   </a:tcPr>
                 </a:tc>
               </a:tr>
-              <a:tr h="256032">
+              <a:tr h="237744">
                 <a:tc>
                   <a:txBody>
                     <a:bodyPr/>
                     <a:lstStyle/>
                     <a:p>
                       <a:r>
-                        <a:rPr b="0" sz="1050">
+                        <a:rPr b="0" sz="850">
                           <a:solidFill>
                             <a:srgbClr val="111111"/>
                           </a:solidFill>
@@ -3621,7 +4184,7 @@
                     <a:lstStyle/>
                     <a:p>
                       <a:r>
-                        <a:rPr b="0" sz="1050">
+                        <a:rPr b="0" sz="850">
                           <a:solidFill>
                             <a:srgbClr val="111111"/>
                           </a:solidFill>
@@ -3642,7 +4205,7 @@
                     <a:lstStyle/>
                     <a:p>
                       <a:r>
-                        <a:rPr b="0" sz="1050">
+                        <a:rPr b="0" sz="850">
                           <a:solidFill>
                             <a:srgbClr val="111111"/>
                           </a:solidFill>
@@ -3658,14 +4221,14 @@
                   </a:tcPr>
                 </a:tc>
               </a:tr>
-              <a:tr h="256032">
+              <a:tr h="237744">
                 <a:tc>
                   <a:txBody>
                     <a:bodyPr/>
                     <a:lstStyle/>
                     <a:p>
                       <a:r>
-                        <a:rPr b="0" sz="1050">
+                        <a:rPr b="0" sz="850">
                           <a:solidFill>
                             <a:srgbClr val="111111"/>
                           </a:solidFill>
@@ -3686,7 +4249,7 @@
                     <a:lstStyle/>
                     <a:p>
                       <a:r>
-                        <a:rPr b="0" sz="1050">
+                        <a:rPr b="0" sz="850">
                           <a:solidFill>
                             <a:srgbClr val="111111"/>
                           </a:solidFill>
@@ -3707,7 +4270,7 @@
                     <a:lstStyle/>
                     <a:p>
                       <a:r>
-                        <a:rPr b="0" sz="1050">
+                        <a:rPr b="0" sz="850">
                           <a:solidFill>
                             <a:srgbClr val="111111"/>
                           </a:solidFill>
@@ -3729,14 +4292,14 @@
       </p:graphicFrame>
       <p:sp>
         <p:nvSpPr>
-          <p:cNvPr id="8" name="TextBox 7"/>
+          <p:cNvPr id="19" name="TextBox 18"/>
           <p:cNvSpPr txBox="1"/>
           <p:nvPr/>
         </p:nvSpPr>
         <p:spPr>
           <a:xfrm>
-            <a:off x="2651760" y="4297680"/>
-            <a:ext cx="4754880" cy="548640"/>
+            <a:off x="548640" y="6812280"/>
+            <a:ext cx="3520440" cy="640080"/>
           </a:xfrm>
           <a:prstGeom prst="rect">
             <a:avLst/>
@@ -3744,442 +4307,38 @@
           <a:noFill/>
         </p:spPr>
         <p:txBody>
-          <a:bodyPr wrap="square" lIns="45720" rIns="45720" tIns="18288" bIns="18288">
+          <a:bodyPr wrap="square" lIns="36576" rIns="36576" tIns="18288" bIns="18288">
             <a:spAutoFit/>
           </a:bodyPr>
           <a:lstStyle/>
           <a:p>
             <a:pPr>
               <a:lnSpc>
-                <a:spcPct val="112000"/>
+                <a:spcPct val="110000"/>
               </a:lnSpc>
             </a:pPr>
             <a:r>
-              <a:rPr sz="1050" b="0" i="0">
+              <a:rPr sz="900" b="0" i="0">
                 <a:solidFill>
                   <a:srgbClr val="555555"/>
                 </a:solidFill>
                 <a:latin typeface="Calibri"/>
               </a:rPr>
-              <a:t>No training, no new labels. Same critic on human egocentric video with only the prompts changed.</a:t>
-            </a:r>
-          </a:p>
-        </p:txBody>
-      </p:sp>
-      <p:sp>
-        <p:nvSpPr>
-          <p:cNvPr id="9" name="TextBox 8"/>
-          <p:cNvSpPr txBox="1"/>
-          <p:nvPr/>
-        </p:nvSpPr>
-        <p:spPr>
-          <a:xfrm>
-            <a:off x="457200" y="5257800"/>
-            <a:ext cx="6949440" cy="292608"/>
-          </a:xfrm>
-          <a:prstGeom prst="rect">
-            <a:avLst/>
-          </a:prstGeom>
-          <a:noFill/>
-        </p:spPr>
-        <p:txBody>
-          <a:bodyPr wrap="square" lIns="45720" rIns="45720" tIns="18288" bIns="18288">
-            <a:spAutoFit/>
-          </a:bodyPr>
-          <a:lstStyle/>
-          <a:p>
-            <a:pPr>
-              <a:lnSpc>
-                <a:spcPct val="112000"/>
-              </a:lnSpc>
-            </a:pPr>
-            <a:r>
-              <a:rPr sz="1250" b="1" i="0">
-                <a:solidFill>
-                  <a:srgbClr val="1982C4"/>
-                </a:solidFill>
-                <a:latin typeface="Calibri"/>
-              </a:rPr>
-              <a:t>UNLABELLED HUMAN VIDEO — 50 CLIPS × 4 SIGNALS, ONE CODE PATH</a:t>
-            </a:r>
-          </a:p>
-        </p:txBody>
-      </p:sp>
-      <p:graphicFrame>
-        <p:nvGraphicFramePr>
-          <p:cNvPr id="10" name="Table 9"/>
-          <p:cNvGraphicFramePr>
-            <a:graphicFrameLocks noGrp="1"/>
-          </p:cNvGraphicFramePr>
-          <p:nvPr/>
-        </p:nvGraphicFramePr>
-        <p:xfrm>
-          <a:off x="457200" y="5559552"/>
-          <a:ext cx="6949440" cy="1024128"/>
-        </p:xfrm>
-        <a:graphic>
-          <a:graphicData uri="http://schemas.openxmlformats.org/drawingml/2006/table">
-            <a:tbl>
-              <a:tblPr firstRow="1" bandRow="1">
-                <a:tableStyleId>{5C22544A-7EE6-4342-B048-85BDC9FD1C3A}</a:tableStyleId>
-              </a:tblPr>
-              <a:tblGrid>
-                <a:gridCol w="3474720"/>
-                <a:gridCol w="1737360"/>
-                <a:gridCol w="1737360"/>
-              </a:tblGrid>
-              <a:tr h="256032">
-                <a:tc>
-                  <a:txBody>
-                    <a:bodyPr/>
-                    <a:lstStyle/>
-                    <a:p>
-                      <a:r>
-                        <a:rPr b="1" sz="950">
-                          <a:solidFill>
-                            <a:srgbClr val="555555"/>
-                          </a:solidFill>
-                        </a:rPr>
-                        <a:t>Signal</a:t>
-                      </a:r>
-                    </a:p>
-                  </a:txBody>
-                  <a:tcPr marL="45720" marR="45720" marT="18288" marB="18288">
-                    <a:solidFill>
-                      <a:srgbClr val="F7F9FC"/>
-                    </a:solidFill>
-                  </a:tcPr>
-                </a:tc>
-                <a:tc>
-                  <a:txBody>
-                    <a:bodyPr/>
-                    <a:lstStyle/>
-                    <a:p>
-                      <a:r>
-                        <a:rPr b="1" sz="950">
-                          <a:solidFill>
-                            <a:srgbClr val="555555"/>
-                          </a:solidFill>
-                        </a:rPr>
-                        <a:t>Tagged success</a:t>
-                      </a:r>
-                    </a:p>
-                  </a:txBody>
-                  <a:tcPr marL="45720" marR="45720" marT="18288" marB="18288">
-                    <a:solidFill>
-                      <a:srgbClr val="F7F9FC"/>
-                    </a:solidFill>
-                  </a:tcPr>
-                </a:tc>
-                <a:tc>
-                  <a:txBody>
-                    <a:bodyPr/>
-                    <a:lstStyle/>
-                    <a:p>
-                      <a:r>
-                        <a:rPr b="1" sz="950">
-                          <a:solidFill>
-                            <a:srgbClr val="555555"/>
-                          </a:solidFill>
-                        </a:rPr>
-                        <a:t>Failure prevalence</a:t>
-                      </a:r>
-                    </a:p>
-                  </a:txBody>
-                  <a:tcPr marL="45720" marR="45720" marT="18288" marB="18288">
-                    <a:solidFill>
-                      <a:srgbClr val="F7F9FC"/>
-                    </a:solidFill>
-                  </a:tcPr>
-                </a:tc>
-              </a:tr>
-              <a:tr h="256032">
-                <a:tc>
-                  <a:txBody>
-                    <a:bodyPr/>
-                    <a:lstStyle/>
-                    <a:p>
-                      <a:r>
-                        <a:rPr b="0" sz="1050">
-                          <a:solidFill>
-                            <a:srgbClr val="111111"/>
-                          </a:solidFill>
-                        </a:rPr>
-                        <a:t>SAM 3 cup-in-saucer</a:t>
-                      </a:r>
-                    </a:p>
-                  </a:txBody>
-                  <a:tcPr marL="45720" marR="45720" marT="18288" marB="18288">
-                    <a:solidFill>
-                      <a:srgbClr val="FFFFFF"/>
-                    </a:solidFill>
-                  </a:tcPr>
-                </a:tc>
-                <a:tc>
-                  <a:txBody>
-                    <a:bodyPr/>
-                    <a:lstStyle/>
-                    <a:p>
-                      <a:r>
-                        <a:rPr b="0" sz="1050">
-                          <a:solidFill>
-                            <a:srgbClr val="111111"/>
-                          </a:solidFill>
-                        </a:rPr>
-                        <a:t>36/50</a:t>
-                      </a:r>
-                    </a:p>
-                  </a:txBody>
-                  <a:tcPr marL="45720" marR="45720" marT="18288" marB="18288">
-                    <a:solidFill>
-                      <a:srgbClr val="FFFFFF"/>
-                    </a:solidFill>
-                  </a:tcPr>
-                </a:tc>
-                <a:tc>
-                  <a:txBody>
-                    <a:bodyPr/>
-                    <a:lstStyle/>
-                    <a:p>
-                      <a:r>
-                        <a:rPr b="0" sz="1050">
-                          <a:solidFill>
-                            <a:srgbClr val="111111"/>
-                          </a:solidFill>
-                        </a:rPr>
-                        <a:t>28%</a:t>
-                      </a:r>
-                    </a:p>
-                  </a:txBody>
-                  <a:tcPr marL="45720" marR="45720" marT="18288" marB="18288">
-                    <a:solidFill>
-                      <a:srgbClr val="FFFFFF"/>
-                    </a:solidFill>
-                  </a:tcPr>
-                </a:tc>
-              </a:tr>
-              <a:tr h="256032">
-                <a:tc>
-                  <a:txBody>
-                    <a:bodyPr/>
-                    <a:lstStyle/>
-                    <a:p>
-                      <a:r>
-                        <a:rPr b="0" sz="1050">
-                          <a:solidFill>
-                            <a:srgbClr val="111111"/>
-                          </a:solidFill>
-                        </a:rPr>
-                        <a:t>Qwen3-VL-8B · PaliGemma2-3B · Cosmos-Reason2-8B</a:t>
-                      </a:r>
-                    </a:p>
-                  </a:txBody>
-                  <a:tcPr marL="45720" marR="45720" marT="18288" marB="18288">
-                    <a:solidFill>
-                      <a:srgbClr val="FFFFFF"/>
-                    </a:solidFill>
-                  </a:tcPr>
-                </a:tc>
-                <a:tc>
-                  <a:txBody>
-                    <a:bodyPr/>
-                    <a:lstStyle/>
-                    <a:p>
-                      <a:r>
-                        <a:rPr b="0" sz="1050">
-                          <a:solidFill>
-                            <a:srgbClr val="111111"/>
-                          </a:solidFill>
-                        </a:rPr>
-                        <a:t>39 · 42 · 34 /50</a:t>
-                      </a:r>
-                    </a:p>
-                  </a:txBody>
-                  <a:tcPr marL="45720" marR="45720" marT="18288" marB="18288">
-                    <a:solidFill>
-                      <a:srgbClr val="FFFFFF"/>
-                    </a:solidFill>
-                  </a:tcPr>
-                </a:tc>
-                <a:tc>
-                  <a:txBody>
-                    <a:bodyPr/>
-                    <a:lstStyle/>
-                    <a:p>
-                      <a:r>
-                        <a:rPr b="0" sz="1050">
-                          <a:solidFill>
-                            <a:srgbClr val="111111"/>
-                          </a:solidFill>
-                        </a:rPr>
-                        <a:t>22 · 16 · 32%</a:t>
-                      </a:r>
-                    </a:p>
-                  </a:txBody>
-                  <a:tcPr marL="45720" marR="45720" marT="18288" marB="18288">
-                    <a:solidFill>
-                      <a:srgbClr val="FFFFFF"/>
-                    </a:solidFill>
-                  </a:tcPr>
-                </a:tc>
-              </a:tr>
-              <a:tr h="256032">
-                <a:tc>
-                  <a:txBody>
-                    <a:bodyPr/>
-                    <a:lstStyle/>
-                    <a:p>
-                      <a:r>
-                        <a:rPr b="1" sz="1050">
-                          <a:solidFill>
-                            <a:srgbClr val="111111"/>
-                          </a:solidFill>
-                        </a:rPr>
-                        <a:t>Fused = mean(SEG, mean of VLMs)</a:t>
-                      </a:r>
-                    </a:p>
-                  </a:txBody>
-                  <a:tcPr marL="45720" marR="45720" marT="18288" marB="18288">
-                    <a:solidFill>
-                      <a:srgbClr val="FFFFFF"/>
-                    </a:solidFill>
-                  </a:tcPr>
-                </a:tc>
-                <a:tc>
-                  <a:txBody>
-                    <a:bodyPr/>
-                    <a:lstStyle/>
-                    <a:p>
-                      <a:r>
-                        <a:rPr b="1" sz="1050">
-                          <a:solidFill>
-                            <a:srgbClr val="111111"/>
-                          </a:solidFill>
-                        </a:rPr>
-                        <a:t>35/50</a:t>
-                      </a:r>
-                    </a:p>
-                  </a:txBody>
-                  <a:tcPr marL="45720" marR="45720" marT="18288" marB="18288">
-                    <a:solidFill>
-                      <a:srgbClr val="FFFFFF"/>
-                    </a:solidFill>
-                  </a:tcPr>
-                </a:tc>
-                <a:tc>
-                  <a:txBody>
-                    <a:bodyPr/>
-                    <a:lstStyle/>
-                    <a:p>
-                      <a:r>
-                        <a:rPr b="1" sz="1050">
-                          <a:solidFill>
-                            <a:srgbClr val="111111"/>
-                          </a:solidFill>
-                        </a:rPr>
-                        <a:t>30%</a:t>
-                      </a:r>
-                    </a:p>
-                  </a:txBody>
-                  <a:tcPr marL="45720" marR="45720" marT="18288" marB="18288">
-                    <a:solidFill>
-                      <a:srgbClr val="FFFFFF"/>
-                    </a:solidFill>
-                  </a:tcPr>
-                </a:tc>
-              </a:tr>
-            </a:tbl>
-          </a:graphicData>
-        </a:graphic>
-      </p:graphicFrame>
-      <p:sp>
-        <p:nvSpPr>
-          <p:cNvPr id="11" name="TextBox 10"/>
-          <p:cNvSpPr txBox="1"/>
-          <p:nvPr/>
-        </p:nvSpPr>
-        <p:spPr>
-          <a:xfrm>
-            <a:off x="457200" y="6629400"/>
-            <a:ext cx="6949440" cy="548640"/>
-          </a:xfrm>
-          <a:prstGeom prst="rect">
-            <a:avLst/>
-          </a:prstGeom>
-          <a:noFill/>
-        </p:spPr>
-        <p:txBody>
-          <a:bodyPr wrap="square" lIns="45720" rIns="45720" tIns="18288" bIns="18288">
-            <a:spAutoFit/>
-          </a:bodyPr>
-          <a:lstStyle/>
-          <a:p>
-            <a:pPr>
-              <a:lnSpc>
-                <a:spcPct val="112000"/>
-              </a:lnSpc>
-            </a:pPr>
-            <a:r>
-              <a:rPr sz="1050" b="0" i="0">
-                <a:solidFill>
-                  <a:srgbClr val="555555"/>
-                </a:solidFill>
-                <a:latin typeface="Calibri"/>
-              </a:rPr>
-              <a:t>27/50 unanimous across all four signals, 37/50 with ≥3 of 4, 6 split 2–2. One 2-min aria video split into 25 attempts → 16 success / 9 failure.</a:t>
-            </a:r>
-          </a:p>
-        </p:txBody>
-      </p:sp>
-      <p:sp>
-        <p:nvSpPr>
-          <p:cNvPr id="12" name="TextBox 11"/>
-          <p:cNvSpPr txBox="1"/>
-          <p:nvPr/>
-        </p:nvSpPr>
-        <p:spPr>
-          <a:xfrm>
-            <a:off x="7863840" y="1005840"/>
-            <a:ext cx="6400800" cy="292608"/>
-          </a:xfrm>
-          <a:prstGeom prst="rect">
-            <a:avLst/>
-          </a:prstGeom>
-          <a:noFill/>
-        </p:spPr>
-        <p:txBody>
-          <a:bodyPr wrap="square" lIns="45720" rIns="45720" tIns="18288" bIns="18288">
-            <a:spAutoFit/>
-          </a:bodyPr>
-          <a:lstStyle/>
-          <a:p>
-            <a:pPr>
-              <a:lnSpc>
-                <a:spcPct val="112000"/>
-              </a:lnSpc>
-            </a:pPr>
-            <a:r>
-              <a:rPr sz="1250" b="1" i="0">
-                <a:solidFill>
-                  <a:srgbClr val="1982C4"/>
-                </a:solidFill>
-                <a:latin typeface="Calibri"/>
-              </a:rPr>
-              <a:t>JUDGING CRITERIA</a:t>
-            </a:r>
-          </a:p>
-        </p:txBody>
-      </p:sp>
-      <p:sp>
-        <p:nvSpPr>
-          <p:cNvPr id="13" name="Rectangle 12"/>
+              <a:t>Gripper proprioception too: zero slips in all 10 failures — failures are hesitation, not drops.</a:t>
+            </a:r>
+          </a:p>
+        </p:txBody>
+      </p:sp>
+      <p:sp>
+        <p:nvSpPr>
+          <p:cNvPr id="20" name="Rectangle 19"/>
           <p:cNvSpPr/>
           <p:nvPr/>
         </p:nvSpPr>
         <p:spPr>
           <a:xfrm>
-            <a:off x="7863840" y="1298448"/>
-            <a:ext cx="3017520" cy="1828800"/>
+            <a:off x="4297680" y="5074920"/>
+            <a:ext cx="3657600" cy="2423160"/>
           </a:xfrm>
           <a:prstGeom prst="rect">
             <a:avLst/>
@@ -4217,14 +4376,14 @@
       </p:sp>
       <p:sp>
         <p:nvSpPr>
-          <p:cNvPr id="14" name="TextBox 13"/>
+          <p:cNvPr id="21" name="TextBox 20"/>
           <p:cNvSpPr txBox="1"/>
           <p:nvPr/>
         </p:nvSpPr>
         <p:spPr>
           <a:xfrm>
-            <a:off x="7909560" y="1344168"/>
-            <a:ext cx="2926080" cy="1783080"/>
+            <a:off x="4389120" y="5120640"/>
+            <a:ext cx="3566160" cy="274320"/>
           </a:xfrm>
           <a:prstGeom prst="rect">
             <a:avLst/>
@@ -4232,54 +4391,176 @@
           <a:noFill/>
         </p:spPr>
         <p:txBody>
-          <a:bodyPr wrap="square" lIns="45720" rIns="45720" tIns="18288" bIns="18288">
+          <a:bodyPr wrap="square" lIns="36576" rIns="36576" tIns="18288" bIns="18288">
             <a:spAutoFit/>
           </a:bodyPr>
           <a:lstStyle/>
           <a:p>
             <a:pPr>
               <a:lnSpc>
-                <a:spcPct val="112000"/>
+                <a:spcPct val="110000"/>
               </a:lnSpc>
             </a:pPr>
             <a:r>
-              <a:rPr sz="1300" b="1" i="0">
-                <a:solidFill>
-                  <a:srgbClr val="111111"/>
+              <a:rPr sz="950" b="1" i="0">
+                <a:solidFill>
+                  <a:srgbClr val="1982C4"/>
                 </a:solidFill>
                 <a:latin typeface="Calibri"/>
               </a:rPr>
-              <a:t>✅ Does it run?</a:t>
-            </a:r>
-          </a:p>
+              <a:t>SIDE EXPERIMENT · ONE 2-MIN EGOCENTRIC VIDEO, SPLIT</a:t>
+            </a:r>
+          </a:p>
+        </p:txBody>
+      </p:sp>
+      <p:pic>
+        <p:nvPicPr>
+          <p:cNvPr id="22" name="Picture 21" descr="2025-11-24-23-59-28-546000_overlay_60pct.jpg"/>
+          <p:cNvPicPr>
+            <a:picLocks noChangeAspect="1"/>
+          </p:cNvPicPr>
+          <p:nvPr/>
+        </p:nvPicPr>
+        <p:blipFill>
+          <a:blip r:embed="rId7"/>
+          <a:stretch>
+            <a:fillRect/>
+          </a:stretch>
+        </p:blipFill>
+        <p:spPr>
+          <a:xfrm>
+            <a:off x="4389120" y="5440680"/>
+            <a:ext cx="1737360" cy="1303020"/>
+          </a:xfrm>
+          <a:prstGeom prst="rect">
+            <a:avLst/>
+          </a:prstGeom>
+        </p:spPr>
+      </p:pic>
+      <p:sp>
+        <p:nvSpPr>
+          <p:cNvPr id="23" name="TextBox 22"/>
+          <p:cNvSpPr txBox="1"/>
+          <p:nvPr/>
+        </p:nvSpPr>
+        <p:spPr>
+          <a:xfrm>
+            <a:off x="6172200" y="5440680"/>
+            <a:ext cx="1737360" cy="2011680"/>
+          </a:xfrm>
+          <a:prstGeom prst="rect">
+            <a:avLst/>
+          </a:prstGeom>
+          <a:noFill/>
+        </p:spPr>
+        <p:txBody>
+          <a:bodyPr wrap="square" lIns="36576" rIns="36576" tIns="18288" bIns="18288">
+            <a:spAutoFit/>
+          </a:bodyPr>
+          <a:lstStyle/>
           <a:p>
             <a:pPr>
               <a:lnSpc>
-                <a:spcPct val="112000"/>
+                <a:spcPct val="110000"/>
               </a:lnSpc>
             </a:pPr>
             <a:r>
-              <a:rPr sz="1050" b="0" i="0">
+              <a:rPr sz="900" b="0" i="0">
                 <a:solidFill>
                   <a:srgbClr val="111111"/>
                 </a:solidFill>
                 <a:latin typeface="Calibri"/>
               </a:rPr>
-              <a:t>Every number here came out of a modal run in the repo today: 5 Modal apps, 3 datasets, 3 VLMs × all 50 human clips + 20 robot episodes. Overlay &amp; meter videos in demo/; graphs, ROC, per-episode verdicts regenerated by one script in results/.</a:t>
-            </a:r>
-          </a:p>
-        </p:txBody>
-      </p:sp>
-      <p:sp>
-        <p:nvSpPr>
-          <p:cNvPr id="15" name="Rectangle 14"/>
+              <a:t>Aria head-cam: both hands, cup, saucer tracked by SAM 3. Segment on cup rests </a:t>
+            </a:r>
+            <a:r>
+              <a:rPr sz="900" b="0" i="1">
+                <a:solidFill>
+                  <a:srgbClr val="111111"/>
+                </a:solidFill>
+                <a:latin typeface="Calibri"/>
+              </a:rPr>
+              <a:t>relative to the saucer</a:t>
+            </a:r>
+            <a:r>
+              <a:rPr sz="900" b="0" i="0">
+                <a:solidFill>
+                  <a:srgbClr val="111111"/>
+                </a:solidFill>
+                <a:latin typeface="Calibri"/>
+              </a:rPr>
+              <a:t> (head motion cancels): </a:t>
+            </a:r>
+            <a:r>
+              <a:rPr sz="900" b="1" i="0">
+                <a:solidFill>
+                  <a:srgbClr val="111111"/>
+                </a:solidFill>
+                <a:latin typeface="Calibri"/>
+              </a:rPr>
+              <a:t>25 attempts → 16 success / 9 failure</a:t>
+            </a:r>
+            <a:r>
+              <a:rPr sz="900" b="0" i="0">
+                <a:solidFill>
+                  <a:srgbClr val="111111"/>
+                </a:solidFill>
+                <a:latin typeface="Calibri"/>
+              </a:rPr>
+              <a:t>, 16 returns not counted.</a:t>
+            </a:r>
+          </a:p>
+        </p:txBody>
+      </p:sp>
+      <p:sp>
+        <p:nvSpPr>
+          <p:cNvPr id="24" name="TextBox 23"/>
+          <p:cNvSpPr txBox="1"/>
+          <p:nvPr/>
+        </p:nvSpPr>
+        <p:spPr>
+          <a:xfrm>
+            <a:off x="8321040" y="960120"/>
+            <a:ext cx="5943600" cy="274320"/>
+          </a:xfrm>
+          <a:prstGeom prst="rect">
+            <a:avLst/>
+          </a:prstGeom>
+          <a:noFill/>
+        </p:spPr>
+        <p:txBody>
+          <a:bodyPr wrap="square" lIns="36576" rIns="36576" tIns="18288" bIns="18288">
+            <a:spAutoFit/>
+          </a:bodyPr>
+          <a:lstStyle/>
+          <a:p>
+            <a:pPr>
+              <a:lnSpc>
+                <a:spcPct val="110000"/>
+              </a:lnSpc>
+            </a:pPr>
+            <a:r>
+              <a:rPr sz="1250" b="1" i="0">
+                <a:solidFill>
+                  <a:srgbClr val="1982C4"/>
+                </a:solidFill>
+                <a:latin typeface="Calibri"/>
+              </a:rPr>
+              <a:t>JUDGING CRITERIA</a:t>
+            </a:r>
+          </a:p>
+        </p:txBody>
+      </p:sp>
+      <p:sp>
+        <p:nvSpPr>
+          <p:cNvPr id="25" name="Rectangle 24"/>
           <p:cNvSpPr/>
           <p:nvPr/>
         </p:nvSpPr>
         <p:spPr>
           <a:xfrm>
-            <a:off x="11018520" y="1298448"/>
-            <a:ext cx="3017520" cy="1828800"/>
+            <a:off x="8321040" y="1243584"/>
+            <a:ext cx="2880360" cy="1691640"/>
           </a:xfrm>
           <a:prstGeom prst="rect">
             <a:avLst/>
@@ -4317,14 +4598,14 @@
       </p:sp>
       <p:sp>
         <p:nvSpPr>
-          <p:cNvPr id="16" name="TextBox 15"/>
+          <p:cNvPr id="26" name="TextBox 25"/>
           <p:cNvSpPr txBox="1"/>
           <p:nvPr/>
         </p:nvSpPr>
         <p:spPr>
           <a:xfrm>
-            <a:off x="11064240" y="1344168"/>
-            <a:ext cx="2926080" cy="1783080"/>
+            <a:off x="8366760" y="1280160"/>
+            <a:ext cx="2788920" cy="1645920"/>
           </a:xfrm>
           <a:prstGeom prst="rect">
             <a:avLst/>
@@ -4332,101 +4613,7 @@
           <a:noFill/>
         </p:spPr>
         <p:txBody>
-          <a:bodyPr wrap="square" lIns="45720" rIns="45720" tIns="18288" bIns="18288">
-            <a:spAutoFit/>
-          </a:bodyPr>
-          <a:lstStyle/>
-          <a:p>
-            <a:pPr>
-              <a:lnSpc>
-                <a:spcPct val="112000"/>
-              </a:lnSpc>
-            </a:pPr>
-            <a:r>
-              <a:rPr sz="1300" b="1" i="0">
-                <a:solidFill>
-                  <a:srgbClr val="111111"/>
-                </a:solidFill>
-                <a:latin typeface="Calibri"/>
-              </a:rPr>
-              <a:t>✅ Is it defensible?</a:t>
-            </a:r>
-          </a:p>
-          <a:p>
-            <a:pPr>
-              <a:lnSpc>
-                <a:spcPct val="112000"/>
-              </a:lnSpc>
-            </a:pPr>
-            <a:r>
-              <a:rPr sz="1050" b="0" i="0">
-                <a:solidFill>
-                  <a:srgbClr val="111111"/>
-                </a:solidFill>
-                <a:latin typeface="Calibri"/>
-              </a:rPr>
-              <a:t>Every choice has a check behind it: gripper polarity verified on the wrist cam; arm frames verified by projecting onto the image; the model's actual top-5 tokens logged on every trace; thresholds fixed at 0.5, AUROC threshold-free; both scoring windows shown for every set.</a:t>
-            </a:r>
-          </a:p>
-        </p:txBody>
-      </p:sp>
-      <p:sp>
-        <p:nvSpPr>
-          <p:cNvPr id="17" name="TextBox 16"/>
-          <p:cNvSpPr txBox="1"/>
-          <p:nvPr/>
-        </p:nvSpPr>
-        <p:spPr>
-          <a:xfrm>
-            <a:off x="7863840" y="3291840"/>
-            <a:ext cx="6400800" cy="292608"/>
-          </a:xfrm>
-          <a:prstGeom prst="rect">
-            <a:avLst/>
-          </a:prstGeom>
-          <a:noFill/>
-        </p:spPr>
-        <p:txBody>
-          <a:bodyPr wrap="square" lIns="45720" rIns="45720" tIns="18288" bIns="18288">
-            <a:spAutoFit/>
-          </a:bodyPr>
-          <a:lstStyle/>
-          <a:p>
-            <a:pPr>
-              <a:lnSpc>
-                <a:spcPct val="112000"/>
-              </a:lnSpc>
-            </a:pPr>
-            <a:r>
-              <a:rPr sz="1250" b="1" i="0">
-                <a:solidFill>
-                  <a:srgbClr val="1982C4"/>
-                </a:solidFill>
-                <a:latin typeface="Calibri"/>
-              </a:rPr>
-              <a:t>WHAT WE LEARNED (AND CAN PROVE)</a:t>
-            </a:r>
-          </a:p>
-        </p:txBody>
-      </p:sp>
-      <p:sp>
-        <p:nvSpPr>
-          <p:cNvPr id="18" name="TextBox 17"/>
-          <p:cNvSpPr txBox="1"/>
-          <p:nvPr/>
-        </p:nvSpPr>
-        <p:spPr>
-          <a:xfrm>
-            <a:off x="7863840" y="3611880"/>
-            <a:ext cx="6309360" cy="2468880"/>
-          </a:xfrm>
-          <a:prstGeom prst="rect">
-            <a:avLst/>
-          </a:prstGeom>
-          <a:noFill/>
-        </p:spPr>
-        <p:txBody>
-          <a:bodyPr wrap="square" lIns="45720" rIns="45720" tIns="18288" bIns="18288">
+          <a:bodyPr wrap="square" lIns="36576" rIns="36576" tIns="18288" bIns="18288">
             <a:spAutoFit/>
           </a:bodyPr>
           <a:lstStyle/>
@@ -4437,22 +4624,13 @@
               </a:lnSpc>
             </a:pPr>
             <a:r>
-              <a:rPr sz="1100" b="1" i="0">
+              <a:rPr sz="1200" b="1" i="0">
                 <a:solidFill>
                   <a:srgbClr val="111111"/>
                 </a:solidFill>
                 <a:latin typeface="Calibri"/>
               </a:rPr>
-              <a:t>1. Ask about the goal state, not "was the task completed?" </a:t>
-            </a:r>
-            <a:r>
-              <a:rPr sz="1100" b="0" i="0">
-                <a:solidFill>
-                  <a:srgbClr val="111111"/>
-                </a:solidFill>
-                <a:latin typeface="Calibri"/>
-              </a:rPr>
-              <a:t>Unanswerable from one frame — p(yes) sat at 10⁻⁴ everywhere while the ranking still worked (AUROC 0.73 → 0.83 after the fix). Smaller model, more literal question: PaliGemma hedged (0.28–0.65) on the generic prompt, decisive (0.07–0.97) on "is the cup resting on the saucer?". Only visible because we read logits.</a:t>
+              <a:t>✅ Does it run?</a:t>
             </a:r>
           </a:p>
           <a:p>
@@ -4462,67 +4640,33 @@
               </a:lnSpc>
             </a:pPr>
             <a:r>
-              <a:rPr sz="1100" b="1" i="0">
+              <a:rPr sz="950" b="0" i="0">
                 <a:solidFill>
                   <a:srgbClr val="111111"/>
                 </a:solidFill>
                 <a:latin typeface="Calibri"/>
               </a:rPr>
-              <a:t>2. Robot failures here are not drops. </a:t>
-            </a:r>
-            <a:r>
-              <a:rPr sz="1100" b="0" i="0">
-                <a:solidFill>
-                  <a:srgbClr val="111111"/>
-                </a:solidFill>
-                <a:latin typeface="Calibri"/>
-              </a:rPr>
-              <a:t>Zero gripper slips across all 10 failures; hesitation — off-hand speed, dominant-arm path length — separates the classes. Geometry flags, VLM adjudicates.</a:t>
-            </a:r>
-          </a:p>
-          <a:p>
-            <a:pPr>
-              <a:lnSpc>
-                <a:spcPct val="110000"/>
-              </a:lnSpc>
-            </a:pPr>
-            <a:r>
-              <a:rPr sz="1100" b="1" i="0">
-                <a:solidFill>
-                  <a:srgbClr val="111111"/>
-                </a:solidFill>
-                <a:latin typeface="Calibri"/>
-              </a:rPr>
-              <a:t>3. The unit of evaluation must match the video. </a:t>
-            </a:r>
-            <a:r>
-              <a:rPr sz="1100" b="0" i="0">
-                <a:solidFill>
-                  <a:srgbClr val="111111"/>
-                </a:solidFill>
-                <a:latin typeface="Calibri"/>
-              </a:rPr>
-              <a:t>A cup50 clip is one attempt — score its end. An aria episode is 25 attempts — segment first (cup speed relative to the saucer, so head motion cancels), then score each.</a:t>
-            </a:r>
-          </a:p>
-        </p:txBody>
-      </p:sp>
-      <p:sp>
-        <p:nvSpPr>
-          <p:cNvPr id="19" name="Rectangle 18"/>
+              <a:t>Every number here came out of a modal run in the repo today: 5 Modal apps, 3 VLMs × all 50 human clips, 20 robot episodes, 20 aria episodes. Overlay &amp; meter videos in demo/; graphs, ROC, per-episode verdicts regenerated by one script in results/.</a:t>
+            </a:r>
+          </a:p>
+        </p:txBody>
+      </p:sp>
+      <p:sp>
+        <p:nvSpPr>
+          <p:cNvPr id="27" name="Rectangle 26"/>
           <p:cNvSpPr/>
           <p:nvPr/>
         </p:nvSpPr>
         <p:spPr>
           <a:xfrm>
-            <a:off x="7863840" y="6172200"/>
-            <a:ext cx="6309360" cy="1234440"/>
+            <a:off x="11338560" y="1243584"/>
+            <a:ext cx="2880360" cy="1691640"/>
           </a:xfrm>
           <a:prstGeom prst="rect">
             <a:avLst/>
           </a:prstGeom>
           <a:solidFill>
-            <a:srgbClr val="FAFAFA"/>
+            <a:srgbClr val="FFFFFF"/>
           </a:solidFill>
           <a:ln>
             <a:solidFill>
@@ -4554,14 +4698,14 @@
       </p:sp>
       <p:sp>
         <p:nvSpPr>
-          <p:cNvPr id="20" name="TextBox 19"/>
+          <p:cNvPr id="28" name="TextBox 27"/>
           <p:cNvSpPr txBox="1"/>
           <p:nvPr/>
         </p:nvSpPr>
         <p:spPr>
           <a:xfrm>
-            <a:off x="7909560" y="6217920"/>
-            <a:ext cx="6217920" cy="1188720"/>
+            <a:off x="11384280" y="1280160"/>
+            <a:ext cx="2788920" cy="1645920"/>
           </a:xfrm>
           <a:prstGeom prst="rect">
             <a:avLst/>
@@ -4569,14 +4713,14 @@
           <a:noFill/>
         </p:spPr>
         <p:txBody>
-          <a:bodyPr wrap="square" lIns="45720" rIns="45720" tIns="18288" bIns="18288">
+          <a:bodyPr wrap="square" lIns="36576" rIns="36576" tIns="18288" bIns="18288">
             <a:spAutoFit/>
           </a:bodyPr>
           <a:lstStyle/>
           <a:p>
             <a:pPr>
               <a:lnSpc>
-                <a:spcPct val="112000"/>
+                <a:spcPct val="110000"/>
               </a:lnSpc>
             </a:pPr>
             <a:r>
@@ -4586,37 +4730,37 @@
                 </a:solidFill>
                 <a:latin typeface="Calibri"/>
               </a:rPr>
-              <a:t>Why it scales to the prevalence problem</a:t>
+              <a:t>✅ Is it defensible?</a:t>
             </a:r>
           </a:p>
           <a:p>
             <a:pPr>
               <a:lnSpc>
-                <a:spcPct val="112000"/>
+                <a:spcPct val="110000"/>
               </a:lnSpc>
             </a:pPr>
             <a:r>
-              <a:rPr sz="1050" b="0" i="0">
+              <a:rPr sz="950" b="0" i="0">
                 <a:solidFill>
                   <a:srgbClr val="111111"/>
                 </a:solidFill>
                 <a:latin typeface="Calibri"/>
               </a:rPr>
-              <a:t>Geometric track is CPU — the whole slice in seconds. SAM 3 is text-prompted from the task description, so no per-episode human seeding. VLM is one batched forward pass per sampled frame (16/pass, H100): 50 clips × 3 models in minutes. A full-dataset sweep is a .map() with per-stage GPUs.</a:t>
-            </a:r>
-          </a:p>
-        </p:txBody>
-      </p:sp>
-      <p:sp>
-        <p:nvSpPr>
-          <p:cNvPr id="21" name="TextBox 20"/>
+              <a:t>Every choice has a check: gripper polarity verified on the wrist cam; arm frames verified by projecting onto the image; the model's actual top-5 tokens logged on every trace; thresholds fixed at 0.5, AUROC threshold-free; both scoring windows shown; disputed clips published, not hidden.</a:t>
+            </a:r>
+          </a:p>
+        </p:txBody>
+      </p:sp>
+      <p:sp>
+        <p:nvSpPr>
+          <p:cNvPr id="29" name="TextBox 28"/>
           <p:cNvSpPr txBox="1"/>
           <p:nvPr/>
         </p:nvSpPr>
         <p:spPr>
           <a:xfrm>
-            <a:off x="457200" y="7635240"/>
-            <a:ext cx="7315200" cy="365760"/>
+            <a:off x="8321040" y="3063240"/>
+            <a:ext cx="5943600" cy="274320"/>
           </a:xfrm>
           <a:prstGeom prst="rect">
             <a:avLst/>
@@ -4624,38 +4768,38 @@
           <a:noFill/>
         </p:spPr>
         <p:txBody>
-          <a:bodyPr wrap="square" lIns="45720" rIns="45720" tIns="18288" bIns="18288">
+          <a:bodyPr wrap="square" lIns="36576" rIns="36576" tIns="18288" bIns="18288">
             <a:spAutoFit/>
           </a:bodyPr>
           <a:lstStyle/>
           <a:p>
             <a:pPr>
               <a:lnSpc>
-                <a:spcPct val="112000"/>
+                <a:spcPct val="110000"/>
               </a:lnSpc>
             </a:pPr>
             <a:r>
-              <a:rPr sz="1050" b="0" i="0">
-                <a:solidFill>
-                  <a:srgbClr val="555555"/>
-                </a:solidFill>
-                <a:latin typeface="Consolas"/>
+              <a:rPr sz="1250" b="1" i="0">
+                <a:solidFill>
+                  <a:srgbClr val="1982C4"/>
+                </a:solidFill>
+                <a:latin typeface="Calibri"/>
               </a:rPr>
-              <a:t>github.com/AungKMin/modal-robotics-hackathon  ·  README → results/ → demo/</a:t>
-            </a:r>
-          </a:p>
-        </p:txBody>
-      </p:sp>
-      <p:sp>
-        <p:nvSpPr>
-          <p:cNvPr id="22" name="TextBox 21"/>
+              <a:t>WHAT WE LEARNED (AND CAN PROVE)</a:t>
+            </a:r>
+          </a:p>
+        </p:txBody>
+      </p:sp>
+      <p:sp>
+        <p:nvSpPr>
+          <p:cNvPr id="30" name="TextBox 29"/>
           <p:cNvSpPr txBox="1"/>
           <p:nvPr/>
         </p:nvSpPr>
         <p:spPr>
           <a:xfrm>
-            <a:off x="7772400" y="7635240"/>
-            <a:ext cx="6400800" cy="365760"/>
+            <a:off x="8321040" y="3346704"/>
+            <a:ext cx="5897880" cy="2011680"/>
           </a:xfrm>
           <a:prstGeom prst="rect">
             <a:avLst/>
@@ -4663,18 +4807,303 @@
           <a:noFill/>
         </p:spPr>
         <p:txBody>
-          <a:bodyPr wrap="square" lIns="45720" rIns="45720" tIns="18288" bIns="18288">
+          <a:bodyPr wrap="square" lIns="36576" rIns="36576" tIns="18288" bIns="18288">
             <a:spAutoFit/>
           </a:bodyPr>
           <a:lstStyle/>
           <a:p>
+            <a:pPr>
+              <a:lnSpc>
+                <a:spcPct val="108000"/>
+              </a:lnSpc>
+            </a:pPr>
+            <a:r>
+              <a:rPr sz="1000" b="1" i="0">
+                <a:solidFill>
+                  <a:srgbClr val="111111"/>
+                </a:solidFill>
+                <a:latin typeface="Calibri"/>
+              </a:rPr>
+              <a:t>1. Ask about the goal state, not "was the task completed?" </a:t>
+            </a:r>
+            <a:r>
+              <a:rPr sz="1000" b="0" i="0">
+                <a:solidFill>
+                  <a:srgbClr val="111111"/>
+                </a:solidFill>
+                <a:latin typeface="Calibri"/>
+              </a:rPr>
+              <a:t>Unanswerable from one frame — p(yes) sat at 10⁻⁴ everywhere while the ranking still worked (AUROC 0.73 → 0.83 after the fix). Smaller model, more literal question: PaliGemma hedged (0.28–0.65) on the generic prompt, decisive (0.07–0.97) on "is the cup resting on the saucer?". Only visible because we read logits.</a:t>
+            </a:r>
+          </a:p>
+          <a:p>
+            <a:pPr>
+              <a:lnSpc>
+                <a:spcPct val="108000"/>
+              </a:lnSpc>
+            </a:pPr>
+            <a:r>
+              <a:rPr sz="1000" b="1" i="0">
+                <a:solidFill>
+                  <a:srgbClr val="111111"/>
+                </a:solidFill>
+                <a:latin typeface="Calibri"/>
+              </a:rPr>
+              <a:t>2. Geometry and language disagree in useful ways. </a:t>
+            </a:r>
+            <a:r>
+              <a:rPr sz="1000" b="0" i="0">
+                <a:solidFill>
+                  <a:srgbClr val="111111"/>
+                </a:solidFill>
+                <a:latin typeface="Calibri"/>
+              </a:rPr>
+              <a:t>Two disputed clips out of 50 are exactly the ones a human should look at; equal weighting means neither signal can outvote the other alone.</a:t>
+            </a:r>
+          </a:p>
+          <a:p>
+            <a:pPr>
+              <a:lnSpc>
+                <a:spcPct val="108000"/>
+              </a:lnSpc>
+            </a:pPr>
+            <a:r>
+              <a:rPr sz="1000" b="1" i="0">
+                <a:solidFill>
+                  <a:srgbClr val="111111"/>
+                </a:solidFill>
+                <a:latin typeface="Calibri"/>
+              </a:rPr>
+              <a:t>3. The unit of evaluation must match the video. </a:t>
+            </a:r>
+            <a:r>
+              <a:rPr sz="1000" b="0" i="0">
+                <a:solidFill>
+                  <a:srgbClr val="111111"/>
+                </a:solidFill>
+                <a:latin typeface="Calibri"/>
+              </a:rPr>
+              <a:t>A cup50 clip is one attempt — score its end. An aria episode is 25 attempts — segment first (cup speed relative to the saucer), then score each.</a:t>
+            </a:r>
+          </a:p>
+        </p:txBody>
+      </p:sp>
+      <p:sp>
+        <p:nvSpPr>
+          <p:cNvPr id="31" name="Rectangle 30"/>
+          <p:cNvSpPr/>
+          <p:nvPr/>
+        </p:nvSpPr>
+        <p:spPr>
+          <a:xfrm>
+            <a:off x="8321040" y="5440680"/>
+            <a:ext cx="5897880" cy="914400"/>
+          </a:xfrm>
+          <a:prstGeom prst="rect">
+            <a:avLst/>
+          </a:prstGeom>
+          <a:solidFill>
+            <a:srgbClr val="FAFAFA"/>
+          </a:solidFill>
+          <a:ln>
+            <a:solidFill>
+              <a:srgbClr val="E6E6E6"/>
+            </a:solidFill>
+          </a:ln>
+        </p:spPr>
+        <p:style>
+          <a:lnRef idx="1">
+            <a:schemeClr val="accent1"/>
+          </a:lnRef>
+          <a:fillRef idx="3">
+            <a:schemeClr val="accent1"/>
+          </a:fillRef>
+          <a:effectRef idx="2">
+            <a:schemeClr val="accent1"/>
+          </a:effectRef>
+          <a:fontRef idx="minor">
+            <a:schemeClr val="lt1"/>
+          </a:fontRef>
+        </p:style>
+        <p:txBody>
+          <a:bodyPr rtlCol="0" anchor="ctr"/>
+          <a:lstStyle/>
+          <a:p>
+            <a:pPr algn="ctr"/>
+          </a:p>
+        </p:txBody>
+      </p:sp>
+      <p:sp>
+        <p:nvSpPr>
+          <p:cNvPr id="32" name="TextBox 31"/>
+          <p:cNvSpPr txBox="1"/>
+          <p:nvPr/>
+        </p:nvSpPr>
+        <p:spPr>
+          <a:xfrm>
+            <a:off x="8366760" y="5468112"/>
+            <a:ext cx="5806440" cy="868680"/>
+          </a:xfrm>
+          <a:prstGeom prst="rect">
+            <a:avLst/>
+          </a:prstGeom>
+          <a:noFill/>
+        </p:spPr>
+        <p:txBody>
+          <a:bodyPr wrap="square" lIns="36576" rIns="36576" tIns="18288" bIns="18288">
+            <a:spAutoFit/>
+          </a:bodyPr>
+          <a:lstStyle/>
+          <a:p>
+            <a:pPr>
+              <a:lnSpc>
+                <a:spcPct val="110000"/>
+              </a:lnSpc>
+            </a:pPr>
+            <a:r>
+              <a:rPr sz="1100" b="1" i="0">
+                <a:solidFill>
+                  <a:srgbClr val="111111"/>
+                </a:solidFill>
+                <a:latin typeface="Calibri"/>
+              </a:rPr>
+              <a:t>Why it scales to the prevalence problem</a:t>
+            </a:r>
+          </a:p>
+          <a:p>
+            <a:pPr>
+              <a:lnSpc>
+                <a:spcPct val="110000"/>
+              </a:lnSpc>
+            </a:pPr>
+            <a:r>
+              <a:rPr sz="950" b="0" i="0">
+                <a:solidFill>
+                  <a:srgbClr val="111111"/>
+                </a:solidFill>
+                <a:latin typeface="Calibri"/>
+              </a:rPr>
+              <a:t>SAM 3 is text-prompted from the task description — no per-episode human seeding. VLM is one batched forward pass per sampled frame (16/pass, H100): 50 clips × 3 models in minutes. A full-dataset sweep is a .map() with per-stage GPUs.</a:t>
+            </a:r>
+          </a:p>
+        </p:txBody>
+      </p:sp>
+      <p:pic>
+        <p:nvPicPr>
+          <p:cNvPr id="33" name="Picture 32" descr="prevalence.png"/>
+          <p:cNvPicPr>
+            <a:picLocks noChangeAspect="1"/>
+          </p:cNvPicPr>
+          <p:nvPr/>
+        </p:nvPicPr>
+        <p:blipFill>
+          <a:blip r:embed="rId8"/>
+          <a:stretch>
+            <a:fillRect/>
+          </a:stretch>
+        </p:blipFill>
+        <p:spPr>
+          <a:xfrm>
+            <a:off x="8321040" y="6446520"/>
+            <a:ext cx="2103120" cy="1051560"/>
+          </a:xfrm>
+          <a:prstGeom prst="rect">
+            <a:avLst/>
+          </a:prstGeom>
+        </p:spPr>
+      </p:pic>
+      <p:pic>
+        <p:nvPicPr>
+          <p:cNvPr id="34" name="Picture 33" descr="agreement_cup50.png"/>
+          <p:cNvPicPr>
+            <a:picLocks noChangeAspect="1"/>
+          </p:cNvPicPr>
+          <p:nvPr/>
+        </p:nvPicPr>
+        <p:blipFill>
+          <a:blip r:embed="rId9"/>
+          <a:stretch>
+            <a:fillRect/>
+          </a:stretch>
+        </p:blipFill>
+        <p:spPr>
+          <a:xfrm>
+            <a:off x="12207240" y="6446520"/>
+            <a:ext cx="1183005" cy="1051560"/>
+          </a:xfrm>
+          <a:prstGeom prst="rect">
+            <a:avLst/>
+          </a:prstGeom>
+        </p:spPr>
+      </p:pic>
+      <p:sp>
+        <p:nvSpPr>
+          <p:cNvPr id="35" name="TextBox 34"/>
+          <p:cNvSpPr txBox="1"/>
+          <p:nvPr/>
+        </p:nvSpPr>
+        <p:spPr>
+          <a:xfrm>
+            <a:off x="457200" y="7680960"/>
+            <a:ext cx="7315200" cy="320040"/>
+          </a:xfrm>
+          <a:prstGeom prst="rect">
+            <a:avLst/>
+          </a:prstGeom>
+          <a:noFill/>
+        </p:spPr>
+        <p:txBody>
+          <a:bodyPr wrap="square" lIns="36576" rIns="36576" tIns="18288" bIns="18288">
+            <a:spAutoFit/>
+          </a:bodyPr>
+          <a:lstStyle/>
+          <a:p>
+            <a:pPr>
+              <a:lnSpc>
+                <a:spcPct val="110000"/>
+              </a:lnSpc>
+            </a:pPr>
+            <a:r>
+              <a:rPr sz="1000" b="0" i="0">
+                <a:solidFill>
+                  <a:srgbClr val="555555"/>
+                </a:solidFill>
+                <a:latin typeface="Consolas"/>
+              </a:rPr>
+              <a:t>github.com/AungKMin/modal-robotics-hackathon  ·  README → results/ → demo/</a:t>
+            </a:r>
+          </a:p>
+        </p:txBody>
+      </p:sp>
+      <p:sp>
+        <p:nvSpPr>
+          <p:cNvPr id="36" name="TextBox 35"/>
+          <p:cNvSpPr txBox="1"/>
+          <p:nvPr/>
+        </p:nvSpPr>
+        <p:spPr>
+          <a:xfrm>
+            <a:off x="7772400" y="7680960"/>
+            <a:ext cx="6400800" cy="320040"/>
+          </a:xfrm>
+          <a:prstGeom prst="rect">
+            <a:avLst/>
+          </a:prstGeom>
+          <a:noFill/>
+        </p:spPr>
+        <p:txBody>
+          <a:bodyPr wrap="square" lIns="36576" rIns="36576" tIns="18288" bIns="18288">
+            <a:spAutoFit/>
+          </a:bodyPr>
+          <a:lstStyle/>
+          <a:p>
             <a:pPr algn="r">
               <a:lnSpc>
-                <a:spcPct val="112000"/>
+                <a:spcPct val="110000"/>
               </a:lnSpc>
             </a:pPr>
             <a:r>
-              <a:rPr sz="1050" b="0" i="0">
+              <a:rPr sz="1000" b="0" i="0">
                 <a:solidFill>
                   <a:srgbClr val="555555"/>
                 </a:solidFill>

</xml_diff>

<commit_message>
3 fps is the canonical cup50 verdict (34/16, 32%); 1 fps kept as the sampling-rate check
Co-Authored-By: Claude Opus 5 (1M context) <noreply@anthropic.com>
</commit_message>
<xml_diff>
--- a/SLIDE.pptx
+++ b/SLIDE.pptx
@@ -3452,7 +3452,7 @@
                             <a:srgbClr val="111111"/>
                           </a:solidFill>
                         </a:rPr>
-                        <a:t>p("Yes") from logits to "is the cup resting on the saucer?", last quarter</a:t>
+                        <a:t>p("Yes") from logits to "is the cup resting on the saucer?", last quarter, 3 fps</a:t>
                       </a:r>
                     </a:p>
                   </a:txBody>
@@ -3473,7 +3473,7 @@
                             <a:srgbClr val="111111"/>
                           </a:solidFill>
                         </a:rPr>
-                        <a:t>39 · 42 · 34</a:t>
+                        <a:t>33 · 41 · 37</a:t>
                       </a:r>
                     </a:p>
                   </a:txBody>
@@ -3494,7 +3494,7 @@
                             <a:srgbClr val="111111"/>
                           </a:solidFill>
                         </a:rPr>
-                        <a:t>22 · 16 · 32%</a:t>
+                        <a:t>34 · 18 · 26%</a:t>
                       </a:r>
                     </a:p>
                   </a:txBody>
@@ -3559,7 +3559,7 @@
                             <a:srgbClr val="111111"/>
                           </a:solidFill>
                         </a:rPr>
-                        <a:t>35/50</a:t>
+                        <a:t>34/50</a:t>
                       </a:r>
                     </a:p>
                   </a:txBody>
@@ -3580,7 +3580,7 @@
                             <a:srgbClr val="111111"/>
                           </a:solidFill>
                         </a:rPr>
-                        <a:t>30%</a:t>
+                        <a:t>32%</a:t>
                       </a:r>
                     </a:p>
                   </a:txBody>
@@ -3629,7 +3629,7 @@
                 </a:solidFill>
                 <a:latin typeface="Calibri"/>
               </a:rPr>
-              <a:t>27/50 unanimous</a:t>
+              <a:t>26/50 unanimous</a:t>
             </a:r>
             <a:r>
               <a:rPr sz="1050" b="0" i="0">
@@ -3638,7 +3638,7 @@
                 </a:solidFill>
                 <a:latin typeface="Calibri"/>
               </a:rPr>
-              <a:t> across all four signals · 37/50 with ≥3 of 4 · 6 split 2–2. Geometry (28%) and language (30%) land on the same prevalence.</a:t>
+              <a:t> across all four signals · 37/50 with ≥3 of 4 · 6 split 2–2. Geometry (28%) and language (32%) land on the same prevalence; 1 fps vs 3 fps sampling changes 1 verdict of 50.</a:t>
             </a:r>
           </a:p>
         </p:txBody>

</xml_diff>

<commit_message>
Regenerate report graphs from the 3 fps cup50 traces; re-embed in slide
Co-Authored-By: Claude Opus 5 (1M context) <noreply@anthropic.com>
</commit_message>
<xml_diff>
--- a/SLIDE.pptx
+++ b/SLIDE.pptx
@@ -4988,16 +4988,94 @@
           </a:p>
         </p:txBody>
       </p:sp>
+      <p:sp>
+        <p:nvSpPr>
+          <p:cNvPr id="35" name="TextBox 34"/>
+          <p:cNvSpPr txBox="1"/>
+          <p:nvPr/>
+        </p:nvSpPr>
+        <p:spPr>
+          <a:xfrm>
+            <a:off x="457200" y="7680960"/>
+            <a:ext cx="7315200" cy="320040"/>
+          </a:xfrm>
+          <a:prstGeom prst="rect">
+            <a:avLst/>
+          </a:prstGeom>
+          <a:noFill/>
+        </p:spPr>
+        <p:txBody>
+          <a:bodyPr wrap="square" lIns="36576" rIns="36576" tIns="18288" bIns="18288">
+            <a:spAutoFit/>
+          </a:bodyPr>
+          <a:lstStyle/>
+          <a:p>
+            <a:pPr>
+              <a:lnSpc>
+                <a:spcPct val="110000"/>
+              </a:lnSpc>
+            </a:pPr>
+            <a:r>
+              <a:rPr sz="1000" b="0" i="0">
+                <a:solidFill>
+                  <a:srgbClr val="555555"/>
+                </a:solidFill>
+                <a:latin typeface="Consolas"/>
+              </a:rPr>
+              <a:t>github.com/AungKMin/modal-robotics-hackathon  ·  README → results/ → demo/</a:t>
+            </a:r>
+          </a:p>
+        </p:txBody>
+      </p:sp>
+      <p:sp>
+        <p:nvSpPr>
+          <p:cNvPr id="36" name="TextBox 35"/>
+          <p:cNvSpPr txBox="1"/>
+          <p:nvPr/>
+        </p:nvSpPr>
+        <p:spPr>
+          <a:xfrm>
+            <a:off x="7772400" y="7680960"/>
+            <a:ext cx="6400800" cy="320040"/>
+          </a:xfrm>
+          <a:prstGeom prst="rect">
+            <a:avLst/>
+          </a:prstGeom>
+          <a:noFill/>
+        </p:spPr>
+        <p:txBody>
+          <a:bodyPr wrap="square" lIns="36576" rIns="36576" tIns="18288" bIns="18288">
+            <a:spAutoFit/>
+          </a:bodyPr>
+          <a:lstStyle/>
+          <a:p>
+            <a:pPr algn="r">
+              <a:lnSpc>
+                <a:spcPct val="110000"/>
+              </a:lnSpc>
+            </a:pPr>
+            <a:r>
+              <a:rPr sz="1000" b="0" i="0">
+                <a:solidFill>
+                  <a:srgbClr val="555555"/>
+                </a:solidFill>
+                <a:latin typeface="Calibri"/>
+              </a:rPr>
+              <a:t>SAM 3 · Qwen3-VL-8B · Cosmos-Reason2-8B · PaliGemma 2 · Modal</a:t>
+            </a:r>
+          </a:p>
+        </p:txBody>
+      </p:sp>
       <p:pic>
         <p:nvPicPr>
-          <p:cNvPr id="33" name="Picture 32" descr="prevalence.png"/>
+          <p:cNvPr id="37" name="Picture 36" descr="prevalence.png"/>
           <p:cNvPicPr>
             <a:picLocks noChangeAspect="1"/>
           </p:cNvPicPr>
           <p:nvPr/>
         </p:nvPicPr>
         <p:blipFill>
-          <a:blip r:embed="rId8"/>
+          <a:blip r:embed="rId10"/>
           <a:stretch>
             <a:fillRect/>
           </a:stretch>
@@ -5014,14 +5092,14 @@
       </p:pic>
       <p:pic>
         <p:nvPicPr>
-          <p:cNvPr id="34" name="Picture 33" descr="agreement_cup50.png"/>
+          <p:cNvPr id="38" name="Picture 37" descr="agreement_cup50.png"/>
           <p:cNvPicPr>
             <a:picLocks noChangeAspect="1"/>
           </p:cNvPicPr>
           <p:nvPr/>
         </p:nvPicPr>
         <p:blipFill>
-          <a:blip r:embed="rId9"/>
+          <a:blip r:embed="rId11"/>
           <a:stretch>
             <a:fillRect/>
           </a:stretch>
@@ -5036,84 +5114,6 @@
           </a:prstGeom>
         </p:spPr>
       </p:pic>
-      <p:sp>
-        <p:nvSpPr>
-          <p:cNvPr id="35" name="TextBox 34"/>
-          <p:cNvSpPr txBox="1"/>
-          <p:nvPr/>
-        </p:nvSpPr>
-        <p:spPr>
-          <a:xfrm>
-            <a:off x="457200" y="7680960"/>
-            <a:ext cx="7315200" cy="320040"/>
-          </a:xfrm>
-          <a:prstGeom prst="rect">
-            <a:avLst/>
-          </a:prstGeom>
-          <a:noFill/>
-        </p:spPr>
-        <p:txBody>
-          <a:bodyPr wrap="square" lIns="36576" rIns="36576" tIns="18288" bIns="18288">
-            <a:spAutoFit/>
-          </a:bodyPr>
-          <a:lstStyle/>
-          <a:p>
-            <a:pPr>
-              <a:lnSpc>
-                <a:spcPct val="110000"/>
-              </a:lnSpc>
-            </a:pPr>
-            <a:r>
-              <a:rPr sz="1000" b="0" i="0">
-                <a:solidFill>
-                  <a:srgbClr val="555555"/>
-                </a:solidFill>
-                <a:latin typeface="Consolas"/>
-              </a:rPr>
-              <a:t>github.com/AungKMin/modal-robotics-hackathon  ·  README → results/ → demo/</a:t>
-            </a:r>
-          </a:p>
-        </p:txBody>
-      </p:sp>
-      <p:sp>
-        <p:nvSpPr>
-          <p:cNvPr id="36" name="TextBox 35"/>
-          <p:cNvSpPr txBox="1"/>
-          <p:nvPr/>
-        </p:nvSpPr>
-        <p:spPr>
-          <a:xfrm>
-            <a:off x="7772400" y="7680960"/>
-            <a:ext cx="6400800" cy="320040"/>
-          </a:xfrm>
-          <a:prstGeom prst="rect">
-            <a:avLst/>
-          </a:prstGeom>
-          <a:noFill/>
-        </p:spPr>
-        <p:txBody>
-          <a:bodyPr wrap="square" lIns="36576" rIns="36576" tIns="18288" bIns="18288">
-            <a:spAutoFit/>
-          </a:bodyPr>
-          <a:lstStyle/>
-          <a:p>
-            <a:pPr algn="r">
-              <a:lnSpc>
-                <a:spcPct val="110000"/>
-              </a:lnSpc>
-            </a:pPr>
-            <a:r>
-              <a:rPr sz="1000" b="0" i="0">
-                <a:solidFill>
-                  <a:srgbClr val="555555"/>
-                </a:solidFill>
-                <a:latin typeface="Calibri"/>
-              </a:rPr>
-              <a:t>SAM 3 · Qwen3-VL-8B · Cosmos-Reason2-8B · PaliGemma 2 · Modal</a:t>
-            </a:r>
-          </a:p>
-        </p:txBody>
-      </p:sp>
     </p:spTree>
   </p:cSld>
   <p:clrMapOvr>

</xml_diff>

<commit_message>
Demo/README/slide captions at 3 fps: both formerly disputed clips resolved toward the geometry
Co-Authored-By: Claude Opus 5 (1M context) <noreply@anthropic.com>
</commit_message>
<xml_diff>
--- a/SLIDE.pptx
+++ b/SLIDE.pptx
@@ -3701,7 +3701,7 @@
                 </a:solidFill>
                 <a:latin typeface="Calibri"/>
               </a:rPr>
-              <a:t>✅ unanimous — SEG 1.00 · VLMs .96/.79/1.00. SAM 3 tracks hand, cup, saucer at 10 fps.</a:t>
+              <a:t>✅ unanimous — SEG 1.00 · VLMs .87/.81/.96. SAM 3 tracks hand, cup, saucer at 10 fps.</a:t>
             </a:r>
           </a:p>
         </p:txBody>
@@ -3827,7 +3827,7 @@
                 </a:solidFill>
                 <a:latin typeface="Calibri"/>
               </a:rPr>
-              <a:t>disputed — SEG 1.00, VLMs .32/.58/.00 → geometry carries it ✅</a:t>
+              <a:t>SEG 1.00, VLMs .74/.46/.63 → ✅ 3/4 — a 2–2 split at 1 fps that 3 fps resolved toward geometry</a:t>
             </a:r>
           </a:p>
         </p:txBody>
@@ -4858,7 +4858,7 @@
                 </a:solidFill>
                 <a:latin typeface="Calibri"/>
               </a:rPr>
-              <a:t>Two disputed clips out of 50 are exactly the ones a human should look at; equal weighting means neither signal can outvote the other alone.</a:t>
+              <a:t>The two clips split at 1 fps both resolved toward the geometry at 3 fps — sampling density matters for the VLMs, not for SEG. Equal weighting means neither signal can outvote the other alone.</a:t>
             </a:r>
           </a:p>
           <a:p>

</xml_diff>